<commit_message>
docs(livrables): theme vert et anthracite, polices Cambria/Calibri, equipe complete, nouvelles captures
Equipe FORTEX : Kephren BIBANG (DEV), Mamadou SECK et Arsene Arayi Mbengue (IA),
Toure Ismahel Ousmane Losseni Junior (INFRA), Raoly KOUMOU (CYBER).
Captures refaites : agent reconnu, compte a rebours intrus, alarmes, surchauffe dans Grafana.

Co-Authored-By: Claude Opus 5.5 <noreply@anthropic.com>
</commit_message>
<xml_diff>
--- a/livrables/Workshop2026-M1-G-Pres.pptx
+++ b/livrables/Workshop2026-M1-G-Pres.pptx
@@ -120,20 +120,20 @@
   <p:extLst>
     <p:ext uri="{521415D9-36F7-43E2-AB2F-B90AF26B5E84}">
       <p14:sectionLst xmlns:p14="http://schemas.microsoft.com/office/powerpoint/2010/main">
-        <p14:section name="Ouverture" id="{2c9dc462-5f2d-7a93-7e1d-3c4d0f9dc132}">
+        <p14:section name="Ouverture" id="{adb2a15a-37eb-d1f8-4bac-ac1e039fc40b}">
           <p14:sldIdLst>
             <p14:sldId id="256"/>
             <p14:sldId id="257"/>
             <p14:sldId id="258"/>
           </p14:sldIdLst>
         </p14:section>
-        <p14:section name="Solution" id="{6312e15f-a1a8-cf0f-9def-6016aa6cb79e}">
+        <p14:section name="Solution" id="{9ab5a250-68f6-949e-bf47-06e0769d206b}">
           <p14:sldIdLst>
             <p14:sldId id="259"/>
             <p14:sldId id="260"/>
           </p14:sldIdLst>
         </p14:section>
-        <p14:section name="Technique" id="{901c4187-384c-6641-61f9-9a2d9c658762}">
+        <p14:section name="Technique" id="{a17063b1-f625-bfe5-dde0-ea837d21fda6}">
           <p14:sldIdLst>
             <p14:sldId id="261"/>
             <p14:sldId id="262"/>
@@ -141,7 +141,7 @@
             <p14:sldId id="264"/>
           </p14:sldIdLst>
         </p14:section>
-        <p14:section name="Bilan" id="{a8480c8d-a025-0495-23f6-f64dbd3ddbb5}">
+        <p14:section name="Bilan" id="{c9bfbee0-3294-b2bb-5066-fd84b19b537f}">
           <p14:sldIdLst>
             <p14:sldId id="265"/>
             <p14:sldId id="266"/>
@@ -1082,7 +1082,7 @@
           <a:p>
             <a:r>
               <a:rPr lang="en-US" dirty="0"/>
-              <a:t>Chacun présente sa filière en une phrase. Compléter le nom du membre CYBER et le numéro de groupe.</a:t>
+              <a:t>Chacun présente sa filière en une phrase. Compléter le numéro de groupe.</a:t>
             </a:r>
             <a:endParaRPr lang="en-US" dirty="0"/>
           </a:p>
@@ -1434,7 +1434,7 @@
           <a:p>
             <a:r>
               <a:rPr lang="en-US" dirty="0"/>
-              <a:t>Une personne inconnue n'est pas une alarme immédiate : on laisse 20 s, avec tolérance si le visage est perdu une seconde. Limite honnête : avec la reconnaissance faciale et le pointage, la latence dépasse parfois 100 ms sur notre PC.</a:t>
+              <a:t>Capture : agent reconnu (cadre vert). Une personne inconnue n'est pas une alarme immédiate : on laisse 20 s, avec tolérance si le visage est perdu une seconde. Limite honnête : avec la reconnaissance faciale et le pointage, la latence dépasse parfois 100 ms sur notre PC.</a:t>
             </a:r>
             <a:endParaRPr lang="en-US" dirty="0"/>
           </a:p>
@@ -1822,9 +1822,9 @@
                 <a:solidFill>
                   <a:schemeClr val="bg1"/>
                 </a:solidFill>
-                <a:latin typeface="Arial" pitchFamily="34" charset="0"/>
-                <a:ea typeface="Arial" pitchFamily="34" charset="-122"/>
-                <a:cs typeface="Arial" pitchFamily="34" charset="-120"/>
+                <a:latin typeface="Cambria" pitchFamily="34" charset="0"/>
+                <a:ea typeface="Cambria" pitchFamily="34" charset="-122"/>
+                <a:cs typeface="Cambria" pitchFamily="34" charset="-120"/>
               </a:defRPr>
             </a:lvl1pPr>
           </a:lstStyle>
@@ -1837,9 +1837,9 @@
                 <a:solidFill>
                   <a:schemeClr val="bg1"/>
                 </a:solidFill>
-                <a:latin typeface="Arial" pitchFamily="34" charset="0"/>
-                <a:ea typeface="Arial" pitchFamily="34" charset="-122"/>
-                <a:cs typeface="Arial" pitchFamily="34" charset="-120"/>
+                <a:latin typeface="Cambria" pitchFamily="34" charset="0"/>
+                <a:ea typeface="Cambria" pitchFamily="34" charset="-122"/>
+                <a:cs typeface="Cambria" pitchFamily="34" charset="-120"/>
               </a:rPr>
               <a:t>Titre</a:t>
             </a:r>
@@ -1960,9 +1960,9 @@
                 <a:solidFill>
                   <a:schemeClr val="tx1"/>
                 </a:solidFill>
-                <a:latin typeface="Arial" pitchFamily="34" charset="0"/>
-                <a:ea typeface="Arial" pitchFamily="34" charset="-122"/>
-                <a:cs typeface="Arial" pitchFamily="34" charset="-120"/>
+                <a:latin typeface="Cambria" pitchFamily="34" charset="0"/>
+                <a:ea typeface="Cambria" pitchFamily="34" charset="-122"/>
+                <a:cs typeface="Cambria" pitchFamily="34" charset="-120"/>
               </a:defRPr>
             </a:lvl1pPr>
           </a:lstStyle>
@@ -1975,9 +1975,9 @@
                 <a:solidFill>
                   <a:schemeClr val="tx1"/>
                 </a:solidFill>
-                <a:latin typeface="Arial" pitchFamily="34" charset="0"/>
-                <a:ea typeface="Arial" pitchFamily="34" charset="-122"/>
-                <a:cs typeface="Arial" pitchFamily="34" charset="-120"/>
+                <a:latin typeface="Cambria" pitchFamily="34" charset="0"/>
+                <a:ea typeface="Cambria" pitchFamily="34" charset="-122"/>
+                <a:cs typeface="Cambria" pitchFamily="34" charset="-120"/>
               </a:rPr>
               <a:t>Titre</a:t>
             </a:r>
@@ -2129,9 +2129,9 @@
                 <a:solidFill>
                   <a:schemeClr val="bg1"/>
                 </a:solidFill>
-                <a:latin typeface="Arial" pitchFamily="34" charset="0"/>
-                <a:ea typeface="Arial" pitchFamily="34" charset="-122"/>
-                <a:cs typeface="Arial" pitchFamily="34" charset="-120"/>
+                <a:latin typeface="Cambria" pitchFamily="34" charset="0"/>
+                <a:ea typeface="Cambria" pitchFamily="34" charset="-122"/>
+                <a:cs typeface="Cambria" pitchFamily="34" charset="-120"/>
               </a:defRPr>
             </a:lvl1pPr>
           </a:lstStyle>
@@ -2144,9 +2144,9 @@
                 <a:solidFill>
                   <a:schemeClr val="bg1"/>
                 </a:solidFill>
-                <a:latin typeface="Arial" pitchFamily="34" charset="0"/>
-                <a:ea typeface="Arial" pitchFamily="34" charset="-122"/>
-                <a:cs typeface="Arial" pitchFamily="34" charset="-120"/>
+                <a:latin typeface="Cambria" pitchFamily="34" charset="0"/>
+                <a:ea typeface="Cambria" pitchFamily="34" charset="-122"/>
+                <a:cs typeface="Cambria" pitchFamily="34" charset="-120"/>
               </a:rPr>
               <a:t>Titre</a:t>
             </a:r>
@@ -2619,11 +2619,11 @@
                 <a:solidFill>
                   <a:schemeClr val="bg1"/>
                 </a:solidFill>
-                <a:latin typeface="Arial" pitchFamily="34" charset="0"/>
-                <a:ea typeface="Arial" pitchFamily="34" charset="-122"/>
-                <a:cs typeface="Arial" pitchFamily="34" charset="-120"/>
-              </a:rPr>
-              <a:t>SENTINEL-X</a:t>
+                <a:latin typeface="Cambria" pitchFamily="34" charset="0"/>
+                <a:ea typeface="Cambria" pitchFamily="34" charset="-122"/>
+                <a:cs typeface="Cambria" pitchFamily="34" charset="-120"/>
+              </a:rPr>
+              <a:t>FORTEX</a:t>
             </a:r>
             <a:endParaRPr lang="en-US" sz="5400" dirty="0"/>
           </a:p>
@@ -2664,7 +2664,7 @@
                 <a:ea typeface="Calibri" pitchFamily="34" charset="-122"/>
                 <a:cs typeface="Calibri" pitchFamily="34" charset="-120"/>
               </a:rPr>
-              <a:t>L'avant-poste industriel du futur · Consortium FORTEX</a:t>
+              <a:t>Mission SENTINEL-X · l'avant-poste industriel du futur</a:t>
             </a:r>
             <a:endParaRPr lang="en-US" sz="2200" dirty="0"/>
           </a:p>
@@ -2685,11 +2685,11 @@
             <a:avLst/>
           </a:prstGeom>
           <a:solidFill>
-            <a:srgbClr val="1C2B3A"/>
+            <a:srgbClr val="353D44"/>
           </a:solidFill>
           <a:ln w="12700">
             <a:solidFill>
-              <a:srgbClr val="1C2B3A"/>
+              <a:srgbClr val="353D44"/>
             </a:solidFill>
             <a:prstDash val="solid"/>
           </a:ln>
@@ -2853,9 +2853,9 @@
                 <a:solidFill>
                   <a:schemeClr val="tx1"/>
                 </a:solidFill>
-                <a:latin typeface="Arial" pitchFamily="34" charset="0"/>
-                <a:ea typeface="Arial" pitchFamily="34" charset="-122"/>
-                <a:cs typeface="Arial" pitchFamily="34" charset="-120"/>
+                <a:latin typeface="Cambria" pitchFamily="34" charset="0"/>
+                <a:ea typeface="Cambria" pitchFamily="34" charset="-122"/>
+                <a:cs typeface="Cambria" pitchFamily="34" charset="-120"/>
               </a:rPr>
               <a:t>Conception et fabrication : outils et choix</a:t>
             </a:r>
@@ -2920,7 +2920,7 @@
                   <a:tcPr marL="101600" marR="101600" marT="50800" marB="50800" anchor="ctr">
                     <a:lnL w="6350" cap="flat" cmpd="sng" algn="ctr">
                       <a:solidFill>
-                        <a:srgbClr val="EEF2F6"/>
+                        <a:srgbClr val="EEF3F0"/>
                       </a:solidFill>
                       <a:prstDash val="solid"/>
                       <a:round/>
@@ -2929,7 +2929,7 @@
                     </a:lnL>
                     <a:lnR w="6350" cap="flat" cmpd="sng" algn="ctr">
                       <a:solidFill>
-                        <a:srgbClr val="EEF2F6"/>
+                        <a:srgbClr val="EEF3F0"/>
                       </a:solidFill>
                       <a:prstDash val="solid"/>
                       <a:round/>
@@ -2938,7 +2938,7 @@
                     </a:lnR>
                     <a:lnT w="6350" cap="flat" cmpd="sng" algn="ctr">
                       <a:solidFill>
-                        <a:srgbClr val="EEF2F6"/>
+                        <a:srgbClr val="EEF3F0"/>
                       </a:solidFill>
                       <a:prstDash val="solid"/>
                       <a:round/>
@@ -2947,7 +2947,7 @@
                     </a:lnT>
                     <a:lnB w="6350" cap="flat" cmpd="sng" algn="ctr">
                       <a:solidFill>
-                        <a:srgbClr val="EEF2F6"/>
+                        <a:srgbClr val="EEF3F0"/>
                       </a:solidFill>
                       <a:prstDash val="solid"/>
                       <a:round/>
@@ -2955,7 +2955,7 @@
                       <a:tailEnd type="none" w="med" len="med"/>
                     </a:lnB>
                     <a:solidFill>
-                      <a:srgbClr val="1C2B3A"/>
+                      <a:srgbClr val="353D44"/>
                     </a:solidFill>
                   </a:tcPr>
                 </a:tc>
@@ -2988,7 +2988,7 @@
                   <a:tcPr marL="101600" marR="101600" marT="50800" marB="50800" anchor="ctr">
                     <a:lnL w="6350" cap="flat" cmpd="sng" algn="ctr">
                       <a:solidFill>
-                        <a:srgbClr val="EEF2F6"/>
+                        <a:srgbClr val="EEF3F0"/>
                       </a:solidFill>
                       <a:prstDash val="solid"/>
                       <a:round/>
@@ -2997,7 +2997,7 @@
                     </a:lnL>
                     <a:lnR w="6350" cap="flat" cmpd="sng" algn="ctr">
                       <a:solidFill>
-                        <a:srgbClr val="EEF2F6"/>
+                        <a:srgbClr val="EEF3F0"/>
                       </a:solidFill>
                       <a:prstDash val="solid"/>
                       <a:round/>
@@ -3006,7 +3006,7 @@
                     </a:lnR>
                     <a:lnT w="6350" cap="flat" cmpd="sng" algn="ctr">
                       <a:solidFill>
-                        <a:srgbClr val="EEF2F6"/>
+                        <a:srgbClr val="EEF3F0"/>
                       </a:solidFill>
                       <a:prstDash val="solid"/>
                       <a:round/>
@@ -3015,7 +3015,7 @@
                     </a:lnT>
                     <a:lnB w="6350" cap="flat" cmpd="sng" algn="ctr">
                       <a:solidFill>
-                        <a:srgbClr val="EEF2F6"/>
+                        <a:srgbClr val="EEF3F0"/>
                       </a:solidFill>
                       <a:prstDash val="solid"/>
                       <a:round/>
@@ -3023,7 +3023,7 @@
                       <a:tailEnd type="none" w="med" len="med"/>
                     </a:lnB>
                     <a:solidFill>
-                      <a:srgbClr val="1C2B3A"/>
+                      <a:srgbClr val="353D44"/>
                     </a:solidFill>
                   </a:tcPr>
                 </a:tc>
@@ -3056,7 +3056,7 @@
                   <a:tcPr marL="101600" marR="101600" marT="50800" marB="50800" anchor="ctr">
                     <a:lnL w="6350" cap="flat" cmpd="sng" algn="ctr">
                       <a:solidFill>
-                        <a:srgbClr val="EEF2F6"/>
+                        <a:srgbClr val="EEF3F0"/>
                       </a:solidFill>
                       <a:prstDash val="solid"/>
                       <a:round/>
@@ -3065,7 +3065,7 @@
                     </a:lnL>
                     <a:lnR w="6350" cap="flat" cmpd="sng" algn="ctr">
                       <a:solidFill>
-                        <a:srgbClr val="EEF2F6"/>
+                        <a:srgbClr val="EEF3F0"/>
                       </a:solidFill>
                       <a:prstDash val="solid"/>
                       <a:round/>
@@ -3074,7 +3074,7 @@
                     </a:lnR>
                     <a:lnT w="6350" cap="flat" cmpd="sng" algn="ctr">
                       <a:solidFill>
-                        <a:srgbClr val="EEF2F6"/>
+                        <a:srgbClr val="EEF3F0"/>
                       </a:solidFill>
                       <a:prstDash val="solid"/>
                       <a:round/>
@@ -3083,7 +3083,7 @@
                     </a:lnT>
                     <a:lnB w="6350" cap="flat" cmpd="sng" algn="ctr">
                       <a:solidFill>
-                        <a:srgbClr val="EEF2F6"/>
+                        <a:srgbClr val="EEF3F0"/>
                       </a:solidFill>
                       <a:prstDash val="solid"/>
                       <a:round/>
@@ -3091,7 +3091,7 @@
                       <a:tailEnd type="none" w="med" len="med"/>
                     </a:lnB>
                     <a:solidFill>
-                      <a:srgbClr val="1C2B3A"/>
+                      <a:srgbClr val="353D44"/>
                     </a:solidFill>
                   </a:tcPr>
                 </a:tc>
@@ -3108,7 +3108,7 @@
                       <a:r>
                         <a:rPr lang="en-US" sz="1400" dirty="0">
                           <a:solidFill>
-                            <a:srgbClr val="1C2B3A"/>
+                            <a:srgbClr val="353D44"/>
                           </a:solidFill>
                           <a:latin typeface="Calibri" pitchFamily="34" charset="0"/>
                           <a:ea typeface="Calibri" pitchFamily="34" charset="-122"/>
@@ -3126,7 +3126,7 @@
                   <a:tcPr marL="101600" marR="101600" marT="50800" marB="50800" anchor="ctr">
                     <a:lnL w="6350" cap="flat" cmpd="sng" algn="ctr">
                       <a:solidFill>
-                        <a:srgbClr val="EEF2F6"/>
+                        <a:srgbClr val="EEF3F0"/>
                       </a:solidFill>
                       <a:prstDash val="solid"/>
                       <a:round/>
@@ -3135,7 +3135,7 @@
                     </a:lnL>
                     <a:lnR w="6350" cap="flat" cmpd="sng" algn="ctr">
                       <a:solidFill>
-                        <a:srgbClr val="EEF2F6"/>
+                        <a:srgbClr val="EEF3F0"/>
                       </a:solidFill>
                       <a:prstDash val="solid"/>
                       <a:round/>
@@ -3144,7 +3144,7 @@
                     </a:lnR>
                     <a:lnT w="6350" cap="flat" cmpd="sng" algn="ctr">
                       <a:solidFill>
-                        <a:srgbClr val="EEF2F6"/>
+                        <a:srgbClr val="EEF3F0"/>
                       </a:solidFill>
                       <a:prstDash val="solid"/>
                       <a:round/>
@@ -3153,7 +3153,7 @@
                     </a:lnT>
                     <a:lnB w="6350" cap="flat" cmpd="sng" algn="ctr">
                       <a:solidFill>
-                        <a:srgbClr val="EEF2F6"/>
+                        <a:srgbClr val="EEF3F0"/>
                       </a:solidFill>
                       <a:prstDash val="solid"/>
                       <a:round/>
@@ -3161,7 +3161,7 @@
                       <a:tailEnd type="none" w="med" len="med"/>
                     </a:lnB>
                     <a:solidFill>
-                      <a:srgbClr val="EEF2F6"/>
+                      <a:srgbClr val="EEF3F0"/>
                     </a:solidFill>
                   </a:tcPr>
                 </a:tc>
@@ -3176,7 +3176,7 @@
                       <a:r>
                         <a:rPr lang="en-US" sz="1400" dirty="0">
                           <a:solidFill>
-                            <a:srgbClr val="1C2B3A"/>
+                            <a:srgbClr val="353D44"/>
                           </a:solidFill>
                           <a:latin typeface="Calibri" pitchFamily="34" charset="0"/>
                           <a:ea typeface="Calibri" pitchFamily="34" charset="-122"/>
@@ -3194,7 +3194,7 @@
                   <a:tcPr marL="101600" marR="101600" marT="50800" marB="50800" anchor="ctr">
                     <a:lnL w="6350" cap="flat" cmpd="sng" algn="ctr">
                       <a:solidFill>
-                        <a:srgbClr val="EEF2F6"/>
+                        <a:srgbClr val="EEF3F0"/>
                       </a:solidFill>
                       <a:prstDash val="solid"/>
                       <a:round/>
@@ -3203,7 +3203,7 @@
                     </a:lnL>
                     <a:lnR w="6350" cap="flat" cmpd="sng" algn="ctr">
                       <a:solidFill>
-                        <a:srgbClr val="EEF2F6"/>
+                        <a:srgbClr val="EEF3F0"/>
                       </a:solidFill>
                       <a:prstDash val="solid"/>
                       <a:round/>
@@ -3212,7 +3212,7 @@
                     </a:lnR>
                     <a:lnT w="6350" cap="flat" cmpd="sng" algn="ctr">
                       <a:solidFill>
-                        <a:srgbClr val="EEF2F6"/>
+                        <a:srgbClr val="EEF3F0"/>
                       </a:solidFill>
                       <a:prstDash val="solid"/>
                       <a:round/>
@@ -3221,7 +3221,7 @@
                     </a:lnT>
                     <a:lnB w="6350" cap="flat" cmpd="sng" algn="ctr">
                       <a:solidFill>
-                        <a:srgbClr val="EEF2F6"/>
+                        <a:srgbClr val="EEF3F0"/>
                       </a:solidFill>
                       <a:prstDash val="solid"/>
                       <a:round/>
@@ -3229,7 +3229,7 @@
                       <a:tailEnd type="none" w="med" len="med"/>
                     </a:lnB>
                     <a:solidFill>
-                      <a:srgbClr val="EEF2F6"/>
+                      <a:srgbClr val="EEF3F0"/>
                     </a:solidFill>
                   </a:tcPr>
                 </a:tc>
@@ -3244,7 +3244,7 @@
                       <a:r>
                         <a:rPr lang="en-US" sz="1400" dirty="0">
                           <a:solidFill>
-                            <a:srgbClr val="1C2B3A"/>
+                            <a:srgbClr val="353D44"/>
                           </a:solidFill>
                           <a:latin typeface="Calibri" pitchFamily="34" charset="0"/>
                           <a:ea typeface="Calibri" pitchFamily="34" charset="-122"/>
@@ -3262,7 +3262,7 @@
                   <a:tcPr marL="101600" marR="101600" marT="50800" marB="50800" anchor="ctr">
                     <a:lnL w="6350" cap="flat" cmpd="sng" algn="ctr">
                       <a:solidFill>
-                        <a:srgbClr val="EEF2F6"/>
+                        <a:srgbClr val="EEF3F0"/>
                       </a:solidFill>
                       <a:prstDash val="solid"/>
                       <a:round/>
@@ -3271,7 +3271,7 @@
                     </a:lnL>
                     <a:lnR w="6350" cap="flat" cmpd="sng" algn="ctr">
                       <a:solidFill>
-                        <a:srgbClr val="EEF2F6"/>
+                        <a:srgbClr val="EEF3F0"/>
                       </a:solidFill>
                       <a:prstDash val="solid"/>
                       <a:round/>
@@ -3280,7 +3280,7 @@
                     </a:lnR>
                     <a:lnT w="6350" cap="flat" cmpd="sng" algn="ctr">
                       <a:solidFill>
-                        <a:srgbClr val="EEF2F6"/>
+                        <a:srgbClr val="EEF3F0"/>
                       </a:solidFill>
                       <a:prstDash val="solid"/>
                       <a:round/>
@@ -3289,7 +3289,7 @@
                     </a:lnT>
                     <a:lnB w="6350" cap="flat" cmpd="sng" algn="ctr">
                       <a:solidFill>
-                        <a:srgbClr val="EEF2F6"/>
+                        <a:srgbClr val="EEF3F0"/>
                       </a:solidFill>
                       <a:prstDash val="solid"/>
                       <a:round/>
@@ -3297,7 +3297,7 @@
                       <a:tailEnd type="none" w="med" len="med"/>
                     </a:lnB>
                     <a:solidFill>
-                      <a:srgbClr val="EEF2F6"/>
+                      <a:srgbClr val="EEF3F0"/>
                     </a:solidFill>
                   </a:tcPr>
                 </a:tc>
@@ -3314,7 +3314,7 @@
                       <a:r>
                         <a:rPr lang="en-US" sz="1400" dirty="0">
                           <a:solidFill>
-                            <a:srgbClr val="1C2B3A"/>
+                            <a:srgbClr val="353D44"/>
                           </a:solidFill>
                           <a:latin typeface="Calibri" pitchFamily="34" charset="0"/>
                           <a:ea typeface="Calibri" pitchFamily="34" charset="-122"/>
@@ -3332,7 +3332,7 @@
                   <a:tcPr marL="101600" marR="101600" marT="50800" marB="50800" anchor="ctr">
                     <a:lnL w="6350" cap="flat" cmpd="sng" algn="ctr">
                       <a:solidFill>
-                        <a:srgbClr val="EEF2F6"/>
+                        <a:srgbClr val="EEF3F0"/>
                       </a:solidFill>
                       <a:prstDash val="solid"/>
                       <a:round/>
@@ -3341,7 +3341,7 @@
                     </a:lnL>
                     <a:lnR w="6350" cap="flat" cmpd="sng" algn="ctr">
                       <a:solidFill>
-                        <a:srgbClr val="EEF2F6"/>
+                        <a:srgbClr val="EEF3F0"/>
                       </a:solidFill>
                       <a:prstDash val="solid"/>
                       <a:round/>
@@ -3350,7 +3350,7 @@
                     </a:lnR>
                     <a:lnT w="6350" cap="flat" cmpd="sng" algn="ctr">
                       <a:solidFill>
-                        <a:srgbClr val="EEF2F6"/>
+                        <a:srgbClr val="EEF3F0"/>
                       </a:solidFill>
                       <a:prstDash val="solid"/>
                       <a:round/>
@@ -3359,7 +3359,7 @@
                     </a:lnT>
                     <a:lnB w="6350" cap="flat" cmpd="sng" algn="ctr">
                       <a:solidFill>
-                        <a:srgbClr val="EEF2F6"/>
+                        <a:srgbClr val="EEF3F0"/>
                       </a:solidFill>
                       <a:prstDash val="solid"/>
                       <a:round/>
@@ -3382,7 +3382,7 @@
                       <a:r>
                         <a:rPr lang="en-US" sz="1400" dirty="0">
                           <a:solidFill>
-                            <a:srgbClr val="1C2B3A"/>
+                            <a:srgbClr val="353D44"/>
                           </a:solidFill>
                           <a:latin typeface="Calibri" pitchFamily="34" charset="0"/>
                           <a:ea typeface="Calibri" pitchFamily="34" charset="-122"/>
@@ -3400,7 +3400,7 @@
                   <a:tcPr marL="101600" marR="101600" marT="50800" marB="50800" anchor="ctr">
                     <a:lnL w="6350" cap="flat" cmpd="sng" algn="ctr">
                       <a:solidFill>
-                        <a:srgbClr val="EEF2F6"/>
+                        <a:srgbClr val="EEF3F0"/>
                       </a:solidFill>
                       <a:prstDash val="solid"/>
                       <a:round/>
@@ -3409,7 +3409,7 @@
                     </a:lnL>
                     <a:lnR w="6350" cap="flat" cmpd="sng" algn="ctr">
                       <a:solidFill>
-                        <a:srgbClr val="EEF2F6"/>
+                        <a:srgbClr val="EEF3F0"/>
                       </a:solidFill>
                       <a:prstDash val="solid"/>
                       <a:round/>
@@ -3418,7 +3418,7 @@
                     </a:lnR>
                     <a:lnT w="6350" cap="flat" cmpd="sng" algn="ctr">
                       <a:solidFill>
-                        <a:srgbClr val="EEF2F6"/>
+                        <a:srgbClr val="EEF3F0"/>
                       </a:solidFill>
                       <a:prstDash val="solid"/>
                       <a:round/>
@@ -3427,7 +3427,7 @@
                     </a:lnT>
                     <a:lnB w="6350" cap="flat" cmpd="sng" algn="ctr">
                       <a:solidFill>
-                        <a:srgbClr val="EEF2F6"/>
+                        <a:srgbClr val="EEF3F0"/>
                       </a:solidFill>
                       <a:prstDash val="solid"/>
                       <a:round/>
@@ -3450,7 +3450,7 @@
                       <a:r>
                         <a:rPr lang="en-US" sz="1400" dirty="0">
                           <a:solidFill>
-                            <a:srgbClr val="1C2B3A"/>
+                            <a:srgbClr val="353D44"/>
                           </a:solidFill>
                           <a:latin typeface="Calibri" pitchFamily="34" charset="0"/>
                           <a:ea typeface="Calibri" pitchFamily="34" charset="-122"/>
@@ -3468,7 +3468,7 @@
                   <a:tcPr marL="101600" marR="101600" marT="50800" marB="50800" anchor="ctr">
                     <a:lnL w="6350" cap="flat" cmpd="sng" algn="ctr">
                       <a:solidFill>
-                        <a:srgbClr val="EEF2F6"/>
+                        <a:srgbClr val="EEF3F0"/>
                       </a:solidFill>
                       <a:prstDash val="solid"/>
                       <a:round/>
@@ -3477,7 +3477,7 @@
                     </a:lnL>
                     <a:lnR w="6350" cap="flat" cmpd="sng" algn="ctr">
                       <a:solidFill>
-                        <a:srgbClr val="EEF2F6"/>
+                        <a:srgbClr val="EEF3F0"/>
                       </a:solidFill>
                       <a:prstDash val="solid"/>
                       <a:round/>
@@ -3486,7 +3486,7 @@
                     </a:lnR>
                     <a:lnT w="6350" cap="flat" cmpd="sng" algn="ctr">
                       <a:solidFill>
-                        <a:srgbClr val="EEF2F6"/>
+                        <a:srgbClr val="EEF3F0"/>
                       </a:solidFill>
                       <a:prstDash val="solid"/>
                       <a:round/>
@@ -3495,7 +3495,7 @@
                     </a:lnT>
                     <a:lnB w="6350" cap="flat" cmpd="sng" algn="ctr">
                       <a:solidFill>
-                        <a:srgbClr val="EEF2F6"/>
+                        <a:srgbClr val="EEF3F0"/>
                       </a:solidFill>
                       <a:prstDash val="solid"/>
                       <a:round/>
@@ -3520,7 +3520,7 @@
                       <a:r>
                         <a:rPr lang="en-US" sz="1400" dirty="0">
                           <a:solidFill>
-                            <a:srgbClr val="1C2B3A"/>
+                            <a:srgbClr val="353D44"/>
                           </a:solidFill>
                           <a:latin typeface="Calibri" pitchFamily="34" charset="0"/>
                           <a:ea typeface="Calibri" pitchFamily="34" charset="-122"/>
@@ -3538,7 +3538,7 @@
                   <a:tcPr marL="101600" marR="101600" marT="50800" marB="50800" anchor="ctr">
                     <a:lnL w="6350" cap="flat" cmpd="sng" algn="ctr">
                       <a:solidFill>
-                        <a:srgbClr val="EEF2F6"/>
+                        <a:srgbClr val="EEF3F0"/>
                       </a:solidFill>
                       <a:prstDash val="solid"/>
                       <a:round/>
@@ -3547,7 +3547,7 @@
                     </a:lnL>
                     <a:lnR w="6350" cap="flat" cmpd="sng" algn="ctr">
                       <a:solidFill>
-                        <a:srgbClr val="EEF2F6"/>
+                        <a:srgbClr val="EEF3F0"/>
                       </a:solidFill>
                       <a:prstDash val="solid"/>
                       <a:round/>
@@ -3556,7 +3556,7 @@
                     </a:lnR>
                     <a:lnT w="6350" cap="flat" cmpd="sng" algn="ctr">
                       <a:solidFill>
-                        <a:srgbClr val="EEF2F6"/>
+                        <a:srgbClr val="EEF3F0"/>
                       </a:solidFill>
                       <a:prstDash val="solid"/>
                       <a:round/>
@@ -3565,7 +3565,7 @@
                     </a:lnT>
                     <a:lnB w="6350" cap="flat" cmpd="sng" algn="ctr">
                       <a:solidFill>
-                        <a:srgbClr val="EEF2F6"/>
+                        <a:srgbClr val="EEF3F0"/>
                       </a:solidFill>
                       <a:prstDash val="solid"/>
                       <a:round/>
@@ -3573,7 +3573,7 @@
                       <a:tailEnd type="none" w="med" len="med"/>
                     </a:lnB>
                     <a:solidFill>
-                      <a:srgbClr val="EEF2F6"/>
+                      <a:srgbClr val="EEF3F0"/>
                     </a:solidFill>
                   </a:tcPr>
                 </a:tc>
@@ -3588,7 +3588,7 @@
                       <a:r>
                         <a:rPr lang="en-US" sz="1400" dirty="0">
                           <a:solidFill>
-                            <a:srgbClr val="1C2B3A"/>
+                            <a:srgbClr val="353D44"/>
                           </a:solidFill>
                           <a:latin typeface="Calibri" pitchFamily="34" charset="0"/>
                           <a:ea typeface="Calibri" pitchFamily="34" charset="-122"/>
@@ -3606,7 +3606,7 @@
                   <a:tcPr marL="101600" marR="101600" marT="50800" marB="50800" anchor="ctr">
                     <a:lnL w="6350" cap="flat" cmpd="sng" algn="ctr">
                       <a:solidFill>
-                        <a:srgbClr val="EEF2F6"/>
+                        <a:srgbClr val="EEF3F0"/>
                       </a:solidFill>
                       <a:prstDash val="solid"/>
                       <a:round/>
@@ -3615,7 +3615,7 @@
                     </a:lnL>
                     <a:lnR w="6350" cap="flat" cmpd="sng" algn="ctr">
                       <a:solidFill>
-                        <a:srgbClr val="EEF2F6"/>
+                        <a:srgbClr val="EEF3F0"/>
                       </a:solidFill>
                       <a:prstDash val="solid"/>
                       <a:round/>
@@ -3624,7 +3624,7 @@
                     </a:lnR>
                     <a:lnT w="6350" cap="flat" cmpd="sng" algn="ctr">
                       <a:solidFill>
-                        <a:srgbClr val="EEF2F6"/>
+                        <a:srgbClr val="EEF3F0"/>
                       </a:solidFill>
                       <a:prstDash val="solid"/>
                       <a:round/>
@@ -3633,7 +3633,7 @@
                     </a:lnT>
                     <a:lnB w="6350" cap="flat" cmpd="sng" algn="ctr">
                       <a:solidFill>
-                        <a:srgbClr val="EEF2F6"/>
+                        <a:srgbClr val="EEF3F0"/>
                       </a:solidFill>
                       <a:prstDash val="solid"/>
                       <a:round/>
@@ -3641,7 +3641,7 @@
                       <a:tailEnd type="none" w="med" len="med"/>
                     </a:lnB>
                     <a:solidFill>
-                      <a:srgbClr val="EEF2F6"/>
+                      <a:srgbClr val="EEF3F0"/>
                     </a:solidFill>
                   </a:tcPr>
                 </a:tc>
@@ -3656,7 +3656,7 @@
                       <a:r>
                         <a:rPr lang="en-US" sz="1400" dirty="0">
                           <a:solidFill>
-                            <a:srgbClr val="1C2B3A"/>
+                            <a:srgbClr val="353D44"/>
                           </a:solidFill>
                           <a:latin typeface="Calibri" pitchFamily="34" charset="0"/>
                           <a:ea typeface="Calibri" pitchFamily="34" charset="-122"/>
@@ -3674,7 +3674,7 @@
                   <a:tcPr marL="101600" marR="101600" marT="50800" marB="50800" anchor="ctr">
                     <a:lnL w="6350" cap="flat" cmpd="sng" algn="ctr">
                       <a:solidFill>
-                        <a:srgbClr val="EEF2F6"/>
+                        <a:srgbClr val="EEF3F0"/>
                       </a:solidFill>
                       <a:prstDash val="solid"/>
                       <a:round/>
@@ -3683,7 +3683,7 @@
                     </a:lnL>
                     <a:lnR w="6350" cap="flat" cmpd="sng" algn="ctr">
                       <a:solidFill>
-                        <a:srgbClr val="EEF2F6"/>
+                        <a:srgbClr val="EEF3F0"/>
                       </a:solidFill>
                       <a:prstDash val="solid"/>
                       <a:round/>
@@ -3692,7 +3692,7 @@
                     </a:lnR>
                     <a:lnT w="6350" cap="flat" cmpd="sng" algn="ctr">
                       <a:solidFill>
-                        <a:srgbClr val="EEF2F6"/>
+                        <a:srgbClr val="EEF3F0"/>
                       </a:solidFill>
                       <a:prstDash val="solid"/>
                       <a:round/>
@@ -3701,7 +3701,7 @@
                     </a:lnT>
                     <a:lnB w="6350" cap="flat" cmpd="sng" algn="ctr">
                       <a:solidFill>
-                        <a:srgbClr val="EEF2F6"/>
+                        <a:srgbClr val="EEF3F0"/>
                       </a:solidFill>
                       <a:prstDash val="solid"/>
                       <a:round/>
@@ -3709,7 +3709,7 @@
                       <a:tailEnd type="none" w="med" len="med"/>
                     </a:lnB>
                     <a:solidFill>
-                      <a:srgbClr val="EEF2F6"/>
+                      <a:srgbClr val="EEF3F0"/>
                     </a:solidFill>
                   </a:tcPr>
                 </a:tc>
@@ -3726,7 +3726,7 @@
                       <a:r>
                         <a:rPr lang="en-US" sz="1400" dirty="0">
                           <a:solidFill>
-                            <a:srgbClr val="1C2B3A"/>
+                            <a:srgbClr val="353D44"/>
                           </a:solidFill>
                           <a:latin typeface="Calibri" pitchFamily="34" charset="0"/>
                           <a:ea typeface="Calibri" pitchFamily="34" charset="-122"/>
@@ -3744,7 +3744,7 @@
                   <a:tcPr marL="101600" marR="101600" marT="50800" marB="50800" anchor="ctr">
                     <a:lnL w="6350" cap="flat" cmpd="sng" algn="ctr">
                       <a:solidFill>
-                        <a:srgbClr val="EEF2F6"/>
+                        <a:srgbClr val="EEF3F0"/>
                       </a:solidFill>
                       <a:prstDash val="solid"/>
                       <a:round/>
@@ -3753,7 +3753,7 @@
                     </a:lnL>
                     <a:lnR w="6350" cap="flat" cmpd="sng" algn="ctr">
                       <a:solidFill>
-                        <a:srgbClr val="EEF2F6"/>
+                        <a:srgbClr val="EEF3F0"/>
                       </a:solidFill>
                       <a:prstDash val="solid"/>
                       <a:round/>
@@ -3762,7 +3762,7 @@
                     </a:lnR>
                     <a:lnT w="6350" cap="flat" cmpd="sng" algn="ctr">
                       <a:solidFill>
-                        <a:srgbClr val="EEF2F6"/>
+                        <a:srgbClr val="EEF3F0"/>
                       </a:solidFill>
                       <a:prstDash val="solid"/>
                       <a:round/>
@@ -3771,7 +3771,7 @@
                     </a:lnT>
                     <a:lnB w="6350" cap="flat" cmpd="sng" algn="ctr">
                       <a:solidFill>
-                        <a:srgbClr val="EEF2F6"/>
+                        <a:srgbClr val="EEF3F0"/>
                       </a:solidFill>
                       <a:prstDash val="solid"/>
                       <a:round/>
@@ -3794,7 +3794,7 @@
                       <a:r>
                         <a:rPr lang="en-US" sz="1400" dirty="0">
                           <a:solidFill>
-                            <a:srgbClr val="1C2B3A"/>
+                            <a:srgbClr val="353D44"/>
                           </a:solidFill>
                           <a:latin typeface="Calibri" pitchFamily="34" charset="0"/>
                           <a:ea typeface="Calibri" pitchFamily="34" charset="-122"/>
@@ -3812,7 +3812,7 @@
                   <a:tcPr marL="101600" marR="101600" marT="50800" marB="50800" anchor="ctr">
                     <a:lnL w="6350" cap="flat" cmpd="sng" algn="ctr">
                       <a:solidFill>
-                        <a:srgbClr val="EEF2F6"/>
+                        <a:srgbClr val="EEF3F0"/>
                       </a:solidFill>
                       <a:prstDash val="solid"/>
                       <a:round/>
@@ -3821,7 +3821,7 @@
                     </a:lnL>
                     <a:lnR w="6350" cap="flat" cmpd="sng" algn="ctr">
                       <a:solidFill>
-                        <a:srgbClr val="EEF2F6"/>
+                        <a:srgbClr val="EEF3F0"/>
                       </a:solidFill>
                       <a:prstDash val="solid"/>
                       <a:round/>
@@ -3830,7 +3830,7 @@
                     </a:lnR>
                     <a:lnT w="6350" cap="flat" cmpd="sng" algn="ctr">
                       <a:solidFill>
-                        <a:srgbClr val="EEF2F6"/>
+                        <a:srgbClr val="EEF3F0"/>
                       </a:solidFill>
                       <a:prstDash val="solid"/>
                       <a:round/>
@@ -3839,7 +3839,7 @@
                     </a:lnT>
                     <a:lnB w="6350" cap="flat" cmpd="sng" algn="ctr">
                       <a:solidFill>
-                        <a:srgbClr val="EEF2F6"/>
+                        <a:srgbClr val="EEF3F0"/>
                       </a:solidFill>
                       <a:prstDash val="solid"/>
                       <a:round/>
@@ -3862,7 +3862,7 @@
                       <a:r>
                         <a:rPr lang="en-US" sz="1400" dirty="0">
                           <a:solidFill>
-                            <a:srgbClr val="1C2B3A"/>
+                            <a:srgbClr val="353D44"/>
                           </a:solidFill>
                           <a:latin typeface="Calibri" pitchFamily="34" charset="0"/>
                           <a:ea typeface="Calibri" pitchFamily="34" charset="-122"/>
@@ -3880,7 +3880,7 @@
                   <a:tcPr marL="101600" marR="101600" marT="50800" marB="50800" anchor="ctr">
                     <a:lnL w="6350" cap="flat" cmpd="sng" algn="ctr">
                       <a:solidFill>
-                        <a:srgbClr val="EEF2F6"/>
+                        <a:srgbClr val="EEF3F0"/>
                       </a:solidFill>
                       <a:prstDash val="solid"/>
                       <a:round/>
@@ -3889,7 +3889,7 @@
                     </a:lnL>
                     <a:lnR w="6350" cap="flat" cmpd="sng" algn="ctr">
                       <a:solidFill>
-                        <a:srgbClr val="EEF2F6"/>
+                        <a:srgbClr val="EEF3F0"/>
                       </a:solidFill>
                       <a:prstDash val="solid"/>
                       <a:round/>
@@ -3898,7 +3898,7 @@
                     </a:lnR>
                     <a:lnT w="6350" cap="flat" cmpd="sng" algn="ctr">
                       <a:solidFill>
-                        <a:srgbClr val="EEF2F6"/>
+                        <a:srgbClr val="EEF3F0"/>
                       </a:solidFill>
                       <a:prstDash val="solid"/>
                       <a:round/>
@@ -3907,7 +3907,7 @@
                     </a:lnT>
                     <a:lnB w="6350" cap="flat" cmpd="sng" algn="ctr">
                       <a:solidFill>
-                        <a:srgbClr val="EEF2F6"/>
+                        <a:srgbClr val="EEF3F0"/>
                       </a:solidFill>
                       <a:prstDash val="solid"/>
                       <a:round/>
@@ -3932,7 +3932,7 @@
                       <a:r>
                         <a:rPr lang="en-US" sz="1400" dirty="0">
                           <a:solidFill>
-                            <a:srgbClr val="1C2B3A"/>
+                            <a:srgbClr val="353D44"/>
                           </a:solidFill>
                           <a:latin typeface="Calibri" pitchFamily="34" charset="0"/>
                           <a:ea typeface="Calibri" pitchFamily="34" charset="-122"/>
@@ -3950,7 +3950,7 @@
                   <a:tcPr marL="101600" marR="101600" marT="50800" marB="50800" anchor="ctr">
                     <a:lnL w="6350" cap="flat" cmpd="sng" algn="ctr">
                       <a:solidFill>
-                        <a:srgbClr val="EEF2F6"/>
+                        <a:srgbClr val="EEF3F0"/>
                       </a:solidFill>
                       <a:prstDash val="solid"/>
                       <a:round/>
@@ -3959,7 +3959,7 @@
                     </a:lnL>
                     <a:lnR w="6350" cap="flat" cmpd="sng" algn="ctr">
                       <a:solidFill>
-                        <a:srgbClr val="EEF2F6"/>
+                        <a:srgbClr val="EEF3F0"/>
                       </a:solidFill>
                       <a:prstDash val="solid"/>
                       <a:round/>
@@ -3968,7 +3968,7 @@
                     </a:lnR>
                     <a:lnT w="6350" cap="flat" cmpd="sng" algn="ctr">
                       <a:solidFill>
-                        <a:srgbClr val="EEF2F6"/>
+                        <a:srgbClr val="EEF3F0"/>
                       </a:solidFill>
                       <a:prstDash val="solid"/>
                       <a:round/>
@@ -3977,7 +3977,7 @@
                     </a:lnT>
                     <a:lnB w="6350" cap="flat" cmpd="sng" algn="ctr">
                       <a:solidFill>
-                        <a:srgbClr val="EEF2F6"/>
+                        <a:srgbClr val="EEF3F0"/>
                       </a:solidFill>
                       <a:prstDash val="solid"/>
                       <a:round/>
@@ -3985,7 +3985,7 @@
                       <a:tailEnd type="none" w="med" len="med"/>
                     </a:lnB>
                     <a:solidFill>
-                      <a:srgbClr val="EEF2F6"/>
+                      <a:srgbClr val="EEF3F0"/>
                     </a:solidFill>
                   </a:tcPr>
                 </a:tc>
@@ -4000,7 +4000,7 @@
                       <a:r>
                         <a:rPr lang="en-US" sz="1400" dirty="0">
                           <a:solidFill>
-                            <a:srgbClr val="1C2B3A"/>
+                            <a:srgbClr val="353D44"/>
                           </a:solidFill>
                           <a:latin typeface="Calibri" pitchFamily="34" charset="0"/>
                           <a:ea typeface="Calibri" pitchFamily="34" charset="-122"/>
@@ -4018,7 +4018,7 @@
                   <a:tcPr marL="101600" marR="101600" marT="50800" marB="50800" anchor="ctr">
                     <a:lnL w="6350" cap="flat" cmpd="sng" algn="ctr">
                       <a:solidFill>
-                        <a:srgbClr val="EEF2F6"/>
+                        <a:srgbClr val="EEF3F0"/>
                       </a:solidFill>
                       <a:prstDash val="solid"/>
                       <a:round/>
@@ -4027,7 +4027,7 @@
                     </a:lnL>
                     <a:lnR w="6350" cap="flat" cmpd="sng" algn="ctr">
                       <a:solidFill>
-                        <a:srgbClr val="EEF2F6"/>
+                        <a:srgbClr val="EEF3F0"/>
                       </a:solidFill>
                       <a:prstDash val="solid"/>
                       <a:round/>
@@ -4036,7 +4036,7 @@
                     </a:lnR>
                     <a:lnT w="6350" cap="flat" cmpd="sng" algn="ctr">
                       <a:solidFill>
-                        <a:srgbClr val="EEF2F6"/>
+                        <a:srgbClr val="EEF3F0"/>
                       </a:solidFill>
                       <a:prstDash val="solid"/>
                       <a:round/>
@@ -4045,7 +4045,7 @@
                     </a:lnT>
                     <a:lnB w="6350" cap="flat" cmpd="sng" algn="ctr">
                       <a:solidFill>
-                        <a:srgbClr val="EEF2F6"/>
+                        <a:srgbClr val="EEF3F0"/>
                       </a:solidFill>
                       <a:prstDash val="solid"/>
                       <a:round/>
@@ -4053,7 +4053,7 @@
                       <a:tailEnd type="none" w="med" len="med"/>
                     </a:lnB>
                     <a:solidFill>
-                      <a:srgbClr val="EEF2F6"/>
+                      <a:srgbClr val="EEF3F0"/>
                     </a:solidFill>
                   </a:tcPr>
                 </a:tc>
@@ -4068,7 +4068,7 @@
                       <a:r>
                         <a:rPr lang="en-US" sz="1400" dirty="0">
                           <a:solidFill>
-                            <a:srgbClr val="1C2B3A"/>
+                            <a:srgbClr val="353D44"/>
                           </a:solidFill>
                           <a:latin typeface="Calibri" pitchFamily="34" charset="0"/>
                           <a:ea typeface="Calibri" pitchFamily="34" charset="-122"/>
@@ -4086,7 +4086,7 @@
                   <a:tcPr marL="101600" marR="101600" marT="50800" marB="50800" anchor="ctr">
                     <a:lnL w="6350" cap="flat" cmpd="sng" algn="ctr">
                       <a:solidFill>
-                        <a:srgbClr val="EEF2F6"/>
+                        <a:srgbClr val="EEF3F0"/>
                       </a:solidFill>
                       <a:prstDash val="solid"/>
                       <a:round/>
@@ -4095,7 +4095,7 @@
                     </a:lnL>
                     <a:lnR w="6350" cap="flat" cmpd="sng" algn="ctr">
                       <a:solidFill>
-                        <a:srgbClr val="EEF2F6"/>
+                        <a:srgbClr val="EEF3F0"/>
                       </a:solidFill>
                       <a:prstDash val="solid"/>
                       <a:round/>
@@ -4104,7 +4104,7 @@
                     </a:lnR>
                     <a:lnT w="6350" cap="flat" cmpd="sng" algn="ctr">
                       <a:solidFill>
-                        <a:srgbClr val="EEF2F6"/>
+                        <a:srgbClr val="EEF3F0"/>
                       </a:solidFill>
                       <a:prstDash val="solid"/>
                       <a:round/>
@@ -4113,7 +4113,7 @@
                     </a:lnT>
                     <a:lnB w="6350" cap="flat" cmpd="sng" algn="ctr">
                       <a:solidFill>
-                        <a:srgbClr val="EEF2F6"/>
+                        <a:srgbClr val="EEF3F0"/>
                       </a:solidFill>
                       <a:prstDash val="solid"/>
                       <a:round/>
@@ -4121,7 +4121,7 @@
                       <a:tailEnd type="none" w="med" len="med"/>
                     </a:lnB>
                     <a:solidFill>
-                      <a:srgbClr val="EEF2F6"/>
+                      <a:srgbClr val="EEF3F0"/>
                     </a:solidFill>
                   </a:tcPr>
                 </a:tc>
@@ -4138,7 +4138,7 @@
                       <a:r>
                         <a:rPr lang="en-US" sz="1400" dirty="0">
                           <a:solidFill>
-                            <a:srgbClr val="1C2B3A"/>
+                            <a:srgbClr val="353D44"/>
                           </a:solidFill>
                           <a:latin typeface="Calibri" pitchFamily="34" charset="0"/>
                           <a:ea typeface="Calibri" pitchFamily="34" charset="-122"/>
@@ -4156,7 +4156,7 @@
                   <a:tcPr marL="101600" marR="101600" marT="50800" marB="50800" anchor="ctr">
                     <a:lnL w="6350" cap="flat" cmpd="sng" algn="ctr">
                       <a:solidFill>
-                        <a:srgbClr val="EEF2F6"/>
+                        <a:srgbClr val="EEF3F0"/>
                       </a:solidFill>
                       <a:prstDash val="solid"/>
                       <a:round/>
@@ -4165,7 +4165,7 @@
                     </a:lnL>
                     <a:lnR w="6350" cap="flat" cmpd="sng" algn="ctr">
                       <a:solidFill>
-                        <a:srgbClr val="EEF2F6"/>
+                        <a:srgbClr val="EEF3F0"/>
                       </a:solidFill>
                       <a:prstDash val="solid"/>
                       <a:round/>
@@ -4174,7 +4174,7 @@
                     </a:lnR>
                     <a:lnT w="6350" cap="flat" cmpd="sng" algn="ctr">
                       <a:solidFill>
-                        <a:srgbClr val="EEF2F6"/>
+                        <a:srgbClr val="EEF3F0"/>
                       </a:solidFill>
                       <a:prstDash val="solid"/>
                       <a:round/>
@@ -4183,7 +4183,7 @@
                     </a:lnT>
                     <a:lnB w="6350" cap="flat" cmpd="sng" algn="ctr">
                       <a:solidFill>
-                        <a:srgbClr val="EEF2F6"/>
+                        <a:srgbClr val="EEF3F0"/>
                       </a:solidFill>
                       <a:prstDash val="solid"/>
                       <a:round/>
@@ -4206,7 +4206,7 @@
                       <a:r>
                         <a:rPr lang="en-US" sz="1400" dirty="0">
                           <a:solidFill>
-                            <a:srgbClr val="1C2B3A"/>
+                            <a:srgbClr val="353D44"/>
                           </a:solidFill>
                           <a:latin typeface="Calibri" pitchFamily="34" charset="0"/>
                           <a:ea typeface="Calibri" pitchFamily="34" charset="-122"/>
@@ -4224,7 +4224,7 @@
                   <a:tcPr marL="101600" marR="101600" marT="50800" marB="50800" anchor="ctr">
                     <a:lnL w="6350" cap="flat" cmpd="sng" algn="ctr">
                       <a:solidFill>
-                        <a:srgbClr val="EEF2F6"/>
+                        <a:srgbClr val="EEF3F0"/>
                       </a:solidFill>
                       <a:prstDash val="solid"/>
                       <a:round/>
@@ -4233,7 +4233,7 @@
                     </a:lnL>
                     <a:lnR w="6350" cap="flat" cmpd="sng" algn="ctr">
                       <a:solidFill>
-                        <a:srgbClr val="EEF2F6"/>
+                        <a:srgbClr val="EEF3F0"/>
                       </a:solidFill>
                       <a:prstDash val="solid"/>
                       <a:round/>
@@ -4242,7 +4242,7 @@
                     </a:lnR>
                     <a:lnT w="6350" cap="flat" cmpd="sng" algn="ctr">
                       <a:solidFill>
-                        <a:srgbClr val="EEF2F6"/>
+                        <a:srgbClr val="EEF3F0"/>
                       </a:solidFill>
                       <a:prstDash val="solid"/>
                       <a:round/>
@@ -4251,7 +4251,7 @@
                     </a:lnT>
                     <a:lnB w="6350" cap="flat" cmpd="sng" algn="ctr">
                       <a:solidFill>
-                        <a:srgbClr val="EEF2F6"/>
+                        <a:srgbClr val="EEF3F0"/>
                       </a:solidFill>
                       <a:prstDash val="solid"/>
                       <a:round/>
@@ -4274,7 +4274,7 @@
                       <a:r>
                         <a:rPr lang="en-US" sz="1400" dirty="0">
                           <a:solidFill>
-                            <a:srgbClr val="1C2B3A"/>
+                            <a:srgbClr val="353D44"/>
                           </a:solidFill>
                           <a:latin typeface="Calibri" pitchFamily="34" charset="0"/>
                           <a:ea typeface="Calibri" pitchFamily="34" charset="-122"/>
@@ -4292,7 +4292,7 @@
                   <a:tcPr marL="101600" marR="101600" marT="50800" marB="50800" anchor="ctr">
                     <a:lnL w="6350" cap="flat" cmpd="sng" algn="ctr">
                       <a:solidFill>
-                        <a:srgbClr val="EEF2F6"/>
+                        <a:srgbClr val="EEF3F0"/>
                       </a:solidFill>
                       <a:prstDash val="solid"/>
                       <a:round/>
@@ -4301,7 +4301,7 @@
                     </a:lnL>
                     <a:lnR w="6350" cap="flat" cmpd="sng" algn="ctr">
                       <a:solidFill>
-                        <a:srgbClr val="EEF2F6"/>
+                        <a:srgbClr val="EEF3F0"/>
                       </a:solidFill>
                       <a:prstDash val="solid"/>
                       <a:round/>
@@ -4310,7 +4310,7 @@
                     </a:lnR>
                     <a:lnT w="6350" cap="flat" cmpd="sng" algn="ctr">
                       <a:solidFill>
-                        <a:srgbClr val="EEF2F6"/>
+                        <a:srgbClr val="EEF3F0"/>
                       </a:solidFill>
                       <a:prstDash val="solid"/>
                       <a:round/>
@@ -4319,7 +4319,7 @@
                     </a:lnT>
                     <a:lnB w="6350" cap="flat" cmpd="sng" algn="ctr">
                       <a:solidFill>
-                        <a:srgbClr val="EEF2F6"/>
+                        <a:srgbClr val="EEF3F0"/>
                       </a:solidFill>
                       <a:prstDash val="solid"/>
                       <a:round/>
@@ -4437,9 +4437,9 @@
                 <a:solidFill>
                   <a:schemeClr val="tx1"/>
                 </a:solidFill>
-                <a:latin typeface="Arial" pitchFamily="34" charset="0"/>
-                <a:ea typeface="Arial" pitchFamily="34" charset="-122"/>
-                <a:cs typeface="Arial" pitchFamily="34" charset="-120"/>
+                <a:latin typeface="Cambria" pitchFamily="34" charset="0"/>
+                <a:ea typeface="Cambria" pitchFamily="34" charset="-122"/>
+                <a:cs typeface="Cambria" pitchFamily="34" charset="-120"/>
               </a:rPr>
               <a:t>Difficultés et limites, sans les cacher</a:t>
             </a:r>
@@ -4464,11 +4464,11 @@
             </a:avLst>
           </a:prstGeom>
           <a:solidFill>
-            <a:srgbClr val="EEF2F6"/>
+            <a:srgbClr val="EEF3F0"/>
           </a:solidFill>
           <a:ln w="12700">
             <a:solidFill>
-              <a:srgbClr val="EEF2F6"/>
+              <a:srgbClr val="EEF3F0"/>
             </a:solidFill>
             <a:prstDash val="solid"/>
           </a:ln>
@@ -4489,11 +4489,11 @@
             <a:avLst/>
           </a:prstGeom>
           <a:solidFill>
-            <a:srgbClr val="FF8A3D"/>
+            <a:srgbClr val="2E9E5B"/>
           </a:solidFill>
           <a:ln w="12700">
             <a:solidFill>
-              <a:srgbClr val="FF8A3D"/>
+              <a:srgbClr val="2E9E5B"/>
             </a:solidFill>
             <a:prstDash val="solid"/>
           </a:ln>
@@ -4552,9 +4552,9 @@
                 <a:solidFill>
                   <a:schemeClr val="tx1"/>
                 </a:solidFill>
-                <a:latin typeface="Arial" pitchFamily="34" charset="0"/>
-                <a:ea typeface="Arial" pitchFamily="34" charset="-122"/>
-                <a:cs typeface="Arial" pitchFamily="34" charset="-120"/>
+                <a:latin typeface="Cambria" pitchFamily="34" charset="0"/>
+                <a:ea typeface="Cambria" pitchFamily="34" charset="-122"/>
+                <a:cs typeface="Cambria" pitchFamily="34" charset="-120"/>
               </a:rPr>
               <a:t>Pas de capteurs physiques</a:t>
             </a:r>
@@ -4618,11 +4618,11 @@
             </a:avLst>
           </a:prstGeom>
           <a:solidFill>
-            <a:srgbClr val="EEF2F6"/>
+            <a:srgbClr val="EEF3F0"/>
           </a:solidFill>
           <a:ln w="12700">
             <a:solidFill>
-              <a:srgbClr val="EEF2F6"/>
+              <a:srgbClr val="EEF3F0"/>
             </a:solidFill>
             <a:prstDash val="solid"/>
           </a:ln>
@@ -4643,11 +4643,11 @@
             <a:avLst/>
           </a:prstGeom>
           <a:solidFill>
-            <a:srgbClr val="FF8A3D"/>
+            <a:srgbClr val="2E9E5B"/>
           </a:solidFill>
           <a:ln w="12700">
             <a:solidFill>
-              <a:srgbClr val="FF8A3D"/>
+              <a:srgbClr val="2E9E5B"/>
             </a:solidFill>
             <a:prstDash val="solid"/>
           </a:ln>
@@ -4706,9 +4706,9 @@
                 <a:solidFill>
                   <a:schemeClr val="tx1"/>
                 </a:solidFill>
-                <a:latin typeface="Arial" pitchFamily="34" charset="0"/>
-                <a:ea typeface="Arial" pitchFamily="34" charset="-122"/>
-                <a:cs typeface="Arial" pitchFamily="34" charset="-120"/>
+                <a:latin typeface="Cambria" pitchFamily="34" charset="0"/>
+                <a:ea typeface="Cambria" pitchFamily="34" charset="-122"/>
+                <a:cs typeface="Cambria" pitchFamily="34" charset="-120"/>
               </a:rPr>
               <a:t>Latence vision</a:t>
             </a:r>
@@ -4772,11 +4772,11 @@
             </a:avLst>
           </a:prstGeom>
           <a:solidFill>
-            <a:srgbClr val="EEF2F6"/>
+            <a:srgbClr val="EEF3F0"/>
           </a:solidFill>
           <a:ln w="12700">
             <a:solidFill>
-              <a:srgbClr val="EEF2F6"/>
+              <a:srgbClr val="EEF3F0"/>
             </a:solidFill>
             <a:prstDash val="solid"/>
           </a:ln>
@@ -4797,11 +4797,11 @@
             <a:avLst/>
           </a:prstGeom>
           <a:solidFill>
-            <a:srgbClr val="FF8A3D"/>
+            <a:srgbClr val="2E9E5B"/>
           </a:solidFill>
           <a:ln w="12700">
             <a:solidFill>
-              <a:srgbClr val="FF8A3D"/>
+              <a:srgbClr val="2E9E5B"/>
             </a:solidFill>
             <a:prstDash val="solid"/>
           </a:ln>
@@ -4860,9 +4860,9 @@
                 <a:solidFill>
                   <a:schemeClr val="tx1"/>
                 </a:solidFill>
-                <a:latin typeface="Arial" pitchFamily="34" charset="0"/>
-                <a:ea typeface="Arial" pitchFamily="34" charset="-122"/>
-                <a:cs typeface="Arial" pitchFamily="34" charset="-120"/>
+                <a:latin typeface="Cambria" pitchFamily="34" charset="0"/>
+                <a:ea typeface="Cambria" pitchFamily="34" charset="-122"/>
+                <a:cs typeface="Cambria" pitchFamily="34" charset="-120"/>
               </a:rPr>
               <a:t>Webcam hors Docker</a:t>
             </a:r>
@@ -4926,11 +4926,11 @@
             </a:avLst>
           </a:prstGeom>
           <a:solidFill>
-            <a:srgbClr val="EEF2F6"/>
+            <a:srgbClr val="EEF3F0"/>
           </a:solidFill>
           <a:ln w="12700">
             <a:solidFill>
-              <a:srgbClr val="EEF2F6"/>
+              <a:srgbClr val="EEF3F0"/>
             </a:solidFill>
             <a:prstDash val="solid"/>
           </a:ln>
@@ -4951,11 +4951,11 @@
             <a:avLst/>
           </a:prstGeom>
           <a:solidFill>
-            <a:srgbClr val="FF8A3D"/>
+            <a:srgbClr val="2E9E5B"/>
           </a:solidFill>
           <a:ln w="12700">
             <a:solidFill>
-              <a:srgbClr val="FF8A3D"/>
+              <a:srgbClr val="2E9E5B"/>
             </a:solidFill>
             <a:prstDash val="solid"/>
           </a:ln>
@@ -5014,9 +5014,9 @@
                 <a:solidFill>
                   <a:schemeClr val="tx1"/>
                 </a:solidFill>
-                <a:latin typeface="Arial" pitchFamily="34" charset="0"/>
-                <a:ea typeface="Arial" pitchFamily="34" charset="-122"/>
-                <a:cs typeface="Arial" pitchFamily="34" charset="-120"/>
+                <a:latin typeface="Cambria" pitchFamily="34" charset="0"/>
+                <a:ea typeface="Cambria" pitchFamily="34" charset="-122"/>
+                <a:cs typeface="Cambria" pitchFamily="34" charset="-120"/>
               </a:rPr>
               <a:t>Intégration à 3 dépôts</a:t>
             </a:r>
@@ -5164,9 +5164,9 @@
                 <a:solidFill>
                   <a:schemeClr val="tx1"/>
                 </a:solidFill>
-                <a:latin typeface="Arial" pitchFamily="34" charset="0"/>
-                <a:ea typeface="Arial" pitchFamily="34" charset="-122"/>
-                <a:cs typeface="Arial" pitchFamily="34" charset="-120"/>
+                <a:latin typeface="Cambria" pitchFamily="34" charset="0"/>
+                <a:ea typeface="Cambria" pitchFamily="34" charset="-122"/>
+                <a:cs typeface="Cambria" pitchFamily="34" charset="-120"/>
               </a:rPr>
               <a:t>Ce que la semaine nous a apporté</a:t>
             </a:r>
@@ -5191,11 +5191,11 @@
             </a:avLst>
           </a:prstGeom>
           <a:solidFill>
-            <a:srgbClr val="EEF2F6"/>
+            <a:srgbClr val="EEF3F0"/>
           </a:solidFill>
           <a:ln w="12700">
             <a:solidFill>
-              <a:srgbClr val="EEF2F6"/>
+              <a:srgbClr val="EEF3F0"/>
             </a:solidFill>
             <a:prstDash val="solid"/>
           </a:ln>
@@ -5230,9 +5230,9 @@
                 <a:solidFill>
                   <a:schemeClr val="accent1"/>
                 </a:solidFill>
-                <a:latin typeface="Arial" pitchFamily="34" charset="0"/>
-                <a:ea typeface="Arial" pitchFamily="34" charset="-122"/>
-                <a:cs typeface="Arial" pitchFamily="34" charset="-120"/>
+                <a:latin typeface="Cambria" pitchFamily="34" charset="0"/>
+                <a:ea typeface="Cambria" pitchFamily="34" charset="-122"/>
+                <a:cs typeface="Cambria" pitchFamily="34" charset="-120"/>
               </a:rPr>
               <a:t>Pour le groupe</a:t>
             </a:r>
@@ -5363,11 +5363,11 @@
             </a:avLst>
           </a:prstGeom>
           <a:solidFill>
-            <a:srgbClr val="EEF2F6"/>
+            <a:srgbClr val="EEF3F0"/>
           </a:solidFill>
           <a:ln w="12700">
             <a:solidFill>
-              <a:srgbClr val="EEF2F6"/>
+              <a:srgbClr val="EEF3F0"/>
             </a:solidFill>
             <a:prstDash val="solid"/>
           </a:ln>
@@ -5402,9 +5402,9 @@
                 <a:solidFill>
                   <a:schemeClr val="accent1"/>
                 </a:solidFill>
-                <a:latin typeface="Arial" pitchFamily="34" charset="0"/>
-                <a:ea typeface="Arial" pitchFamily="34" charset="-122"/>
-                <a:cs typeface="Arial" pitchFamily="34" charset="-120"/>
+                <a:latin typeface="Cambria" pitchFamily="34" charset="0"/>
+                <a:ea typeface="Cambria" pitchFamily="34" charset="-122"/>
+                <a:cs typeface="Cambria" pitchFamily="34" charset="-120"/>
               </a:rPr>
               <a:t>Individuellement</a:t>
             </a:r>
@@ -5421,7 +5421,7 @@
         <p:spPr>
           <a:xfrm>
             <a:off x="6492240" y="2103120"/>
-            <a:ext cx="4846320" cy="3566160"/>
+            <a:ext cx="4846320" cy="3657600"/>
           </a:xfrm>
           <a:prstGeom prst="rect">
             <a:avLst/>
@@ -5435,12 +5435,12 @@
           <a:p>
             <a:pPr indent="0" marL="0">
               <a:spcAft>
-                <a:spcPts val="1200"/>
+                <a:spcPts val="800"/>
               </a:spcAft>
               <a:buNone/>
             </a:pPr>
             <a:r>
-              <a:rPr lang="en-US" sz="1600" b="1" dirty="0">
+              <a:rPr lang="en-US" sz="1500" b="1" dirty="0">
                 <a:solidFill>
                   <a:schemeClr val="tx2"/>
                 </a:solidFill>
@@ -5448,16 +5448,16 @@
                 <a:ea typeface="Calibri" pitchFamily="34" charset="-122"/>
                 <a:cs typeface="Calibri" pitchFamily="34" charset="-120"/>
               </a:rPr>
-              <a:t>Mamadou (IA) : </a:t>
+              <a:t>Mamadou SECK (IA) : </a:t>
             </a:r>
             <a:pPr indent="0" marL="0">
               <a:spcAft>
-                <a:spcPts val="1200"/>
+                <a:spcPts val="800"/>
               </a:spcAft>
               <a:buNone/>
             </a:pPr>
             <a:r>
-              <a:rPr lang="en-US" sz="1600" dirty="0">
+              <a:rPr lang="en-US" sz="1500" dirty="0">
                 <a:solidFill>
                   <a:schemeClr val="tx2"/>
                 </a:solidFill>
@@ -5465,19 +5465,19 @@
                 <a:ea typeface="Calibri" pitchFamily="34" charset="-122"/>
                 <a:cs typeface="Calibri" pitchFamily="34" charset="-120"/>
               </a:rPr>
-              <a:t>IA embarquée temps réel et détection d'anomalies non supervisée</a:t>
-            </a:r>
-            <a:endParaRPr lang="en-US" sz="1600" dirty="0"/>
+              <a:t>IA embarquée temps réel, détection d'anomalies</a:t>
+            </a:r>
+            <a:endParaRPr lang="en-US" sz="1500" dirty="0"/>
           </a:p>
           <a:p>
             <a:pPr indent="0" marL="0">
               <a:spcAft>
-                <a:spcPts val="1200"/>
+                <a:spcPts val="800"/>
               </a:spcAft>
               <a:buNone/>
             </a:pPr>
             <a:r>
-              <a:rPr lang="en-US" sz="1600" b="1" dirty="0">
+              <a:rPr lang="en-US" sz="1500" b="1" dirty="0">
                 <a:solidFill>
                   <a:schemeClr val="tx2"/>
                 </a:solidFill>
@@ -5485,16 +5485,16 @@
                 <a:ea typeface="Calibri" pitchFamily="34" charset="-122"/>
                 <a:cs typeface="Calibri" pitchFamily="34" charset="-120"/>
               </a:rPr>
-              <a:t>Kephren (DEV) : </a:t>
+              <a:t>Arsene Arayi Mbengue (IA) : </a:t>
             </a:r>
             <a:pPr indent="0" marL="0">
               <a:spcAft>
-                <a:spcPts val="1200"/>
+                <a:spcPts val="800"/>
               </a:spcAft>
               <a:buNone/>
             </a:pPr>
             <a:r>
-              <a:rPr lang="en-US" sz="1600" dirty="0">
+              <a:rPr lang="en-US" sz="1500" dirty="0">
                 <a:solidFill>
                   <a:schemeClr val="tx2"/>
                 </a:solidFill>
@@ -5504,17 +5504,17 @@
               </a:rPr>
               <a:t>[à compléter]</a:t>
             </a:r>
-            <a:endParaRPr lang="en-US" sz="1600" dirty="0"/>
+            <a:endParaRPr lang="en-US" sz="1500" dirty="0"/>
           </a:p>
           <a:p>
             <a:pPr indent="0" marL="0">
               <a:spcAft>
-                <a:spcPts val="1200"/>
+                <a:spcPts val="800"/>
               </a:spcAft>
               <a:buNone/>
             </a:pPr>
             <a:r>
-              <a:rPr lang="en-US" sz="1600" b="1" dirty="0">
+              <a:rPr lang="en-US" sz="1500" b="1" dirty="0">
                 <a:solidFill>
                   <a:schemeClr val="tx2"/>
                 </a:solidFill>
@@ -5522,16 +5522,16 @@
                 <a:ea typeface="Calibri" pitchFamily="34" charset="-122"/>
                 <a:cs typeface="Calibri" pitchFamily="34" charset="-120"/>
               </a:rPr>
-              <a:t>Ismahel (INFRA) : </a:t>
+              <a:t>Kephren BIBANG (DEV) : </a:t>
             </a:r>
             <a:pPr indent="0" marL="0">
               <a:spcAft>
-                <a:spcPts val="1200"/>
+                <a:spcPts val="800"/>
               </a:spcAft>
               <a:buNone/>
             </a:pPr>
             <a:r>
-              <a:rPr lang="en-US" sz="1600" dirty="0">
+              <a:rPr lang="en-US" sz="1500" dirty="0">
                 <a:solidFill>
                   <a:schemeClr val="tx2"/>
                 </a:solidFill>
@@ -5541,17 +5541,17 @@
               </a:rPr>
               <a:t>[à compléter]</a:t>
             </a:r>
-            <a:endParaRPr lang="en-US" sz="1600" dirty="0"/>
+            <a:endParaRPr lang="en-US" sz="1500" dirty="0"/>
           </a:p>
           <a:p>
             <a:pPr indent="0" marL="0">
               <a:spcAft>
-                <a:spcPts val="1200"/>
+                <a:spcPts val="800"/>
               </a:spcAft>
               <a:buNone/>
             </a:pPr>
             <a:r>
-              <a:rPr lang="en-US" sz="1600" b="1" dirty="0">
+              <a:rPr lang="en-US" sz="1500" b="1" dirty="0">
                 <a:solidFill>
                   <a:schemeClr val="tx2"/>
                 </a:solidFill>
@@ -5559,16 +5559,16 @@
                 <a:ea typeface="Calibri" pitchFamily="34" charset="-122"/>
                 <a:cs typeface="Calibri" pitchFamily="34" charset="-120"/>
               </a:rPr>
-              <a:t>[Nom] (CYBER) : </a:t>
+              <a:t>Toure Ismahel (INFRA) : </a:t>
             </a:r>
             <a:pPr indent="0" marL="0">
               <a:spcAft>
-                <a:spcPts val="1200"/>
+                <a:spcPts val="800"/>
               </a:spcAft>
               <a:buNone/>
             </a:pPr>
             <a:r>
-              <a:rPr lang="en-US" sz="1600" dirty="0">
+              <a:rPr lang="en-US" sz="1500" dirty="0">
                 <a:solidFill>
                   <a:schemeClr val="tx2"/>
                 </a:solidFill>
@@ -5578,7 +5578,44 @@
               </a:rPr>
               <a:t>[à compléter]</a:t>
             </a:r>
-            <a:endParaRPr lang="en-US" sz="1600" dirty="0"/>
+            <a:endParaRPr lang="en-US" sz="1500" dirty="0"/>
+          </a:p>
+          <a:p>
+            <a:pPr indent="0" marL="0">
+              <a:spcAft>
+                <a:spcPts val="800"/>
+              </a:spcAft>
+              <a:buNone/>
+            </a:pPr>
+            <a:r>
+              <a:rPr lang="en-US" sz="1500" b="1" dirty="0">
+                <a:solidFill>
+                  <a:schemeClr val="tx2"/>
+                </a:solidFill>
+                <a:latin typeface="Calibri" pitchFamily="34" charset="0"/>
+                <a:ea typeface="Calibri" pitchFamily="34" charset="-122"/>
+                <a:cs typeface="Calibri" pitchFamily="34" charset="-120"/>
+              </a:rPr>
+              <a:t>Raoly KOUMOU (CYBER) : </a:t>
+            </a:r>
+            <a:pPr indent="0" marL="0">
+              <a:spcAft>
+                <a:spcPts val="800"/>
+              </a:spcAft>
+              <a:buNone/>
+            </a:pPr>
+            <a:r>
+              <a:rPr lang="en-US" sz="1500" dirty="0">
+                <a:solidFill>
+                  <a:schemeClr val="tx2"/>
+                </a:solidFill>
+                <a:latin typeface="Calibri" pitchFamily="34" charset="0"/>
+                <a:ea typeface="Calibri" pitchFamily="34" charset="-122"/>
+                <a:cs typeface="Calibri" pitchFamily="34" charset="-120"/>
+              </a:rPr>
+              <a:t>[à compléter]</a:t>
+            </a:r>
+            <a:endParaRPr lang="en-US" sz="1500" dirty="0"/>
           </a:p>
         </p:txBody>
       </p:sp>
@@ -5683,9 +5720,9 @@
                 <a:solidFill>
                   <a:schemeClr val="tx1"/>
                 </a:solidFill>
-                <a:latin typeface="Arial" pitchFamily="34" charset="0"/>
-                <a:ea typeface="Arial" pitchFamily="34" charset="-122"/>
-                <a:cs typeface="Arial" pitchFamily="34" charset="-120"/>
+                <a:latin typeface="Cambria" pitchFamily="34" charset="0"/>
+                <a:ea typeface="Cambria" pitchFamily="34" charset="-122"/>
+                <a:cs typeface="Cambria" pitchFamily="34" charset="-120"/>
               </a:rPr>
               <a:t>Améliorations possibles</a:t>
             </a:r>
@@ -5708,11 +5745,11 @@
             <a:avLst/>
           </a:prstGeom>
           <a:solidFill>
-            <a:srgbClr val="2EC4B6"/>
+            <a:srgbClr val="2E9E5B"/>
           </a:solidFill>
           <a:ln w="12700">
             <a:solidFill>
-              <a:srgbClr val="2EC4B6"/>
+              <a:srgbClr val="2E9E5B"/>
             </a:solidFill>
             <a:prstDash val="solid"/>
           </a:ln>
@@ -5771,9 +5808,9 @@
                 <a:solidFill>
                   <a:schemeClr val="tx1"/>
                 </a:solidFill>
-                <a:latin typeface="Arial" pitchFamily="34" charset="0"/>
-                <a:ea typeface="Arial" pitchFamily="34" charset="-122"/>
-                <a:cs typeface="Arial" pitchFamily="34" charset="-120"/>
+                <a:latin typeface="Cambria" pitchFamily="34" charset="0"/>
+                <a:ea typeface="Cambria" pitchFamily="34" charset="-122"/>
+                <a:cs typeface="Cambria" pitchFamily="34" charset="-120"/>
               </a:rPr>
               <a:t>Boîtier réel</a:t>
             </a:r>
@@ -5835,11 +5872,11 @@
             <a:avLst/>
           </a:prstGeom>
           <a:solidFill>
-            <a:srgbClr val="2EC4B6"/>
+            <a:srgbClr val="2E9E5B"/>
           </a:solidFill>
           <a:ln w="12700">
             <a:solidFill>
-              <a:srgbClr val="2EC4B6"/>
+              <a:srgbClr val="2E9E5B"/>
             </a:solidFill>
             <a:prstDash val="solid"/>
           </a:ln>
@@ -5898,9 +5935,9 @@
                 <a:solidFill>
                   <a:schemeClr val="tx1"/>
                 </a:solidFill>
-                <a:latin typeface="Arial" pitchFamily="34" charset="0"/>
-                <a:ea typeface="Arial" pitchFamily="34" charset="-122"/>
-                <a:cs typeface="Arial" pitchFamily="34" charset="-120"/>
+                <a:latin typeface="Cambria" pitchFamily="34" charset="0"/>
+                <a:ea typeface="Cambria" pitchFamily="34" charset="-122"/>
+                <a:cs typeface="Cambria" pitchFamily="34" charset="-120"/>
               </a:rPr>
               <a:t>Vision plus rapide</a:t>
             </a:r>
@@ -5962,11 +5999,11 @@
             <a:avLst/>
           </a:prstGeom>
           <a:solidFill>
-            <a:srgbClr val="2EC4B6"/>
+            <a:srgbClr val="2E9E5B"/>
           </a:solidFill>
           <a:ln w="12700">
             <a:solidFill>
-              <a:srgbClr val="2EC4B6"/>
+              <a:srgbClr val="2E9E5B"/>
             </a:solidFill>
             <a:prstDash val="solid"/>
           </a:ln>
@@ -6025,9 +6062,9 @@
                 <a:solidFill>
                   <a:schemeClr val="tx1"/>
                 </a:solidFill>
-                <a:latin typeface="Arial" pitchFamily="34" charset="0"/>
-                <a:ea typeface="Arial" pitchFamily="34" charset="-122"/>
-                <a:cs typeface="Arial" pitchFamily="34" charset="-120"/>
+                <a:latin typeface="Cambria" pitchFamily="34" charset="0"/>
+                <a:ea typeface="Cambria" pitchFamily="34" charset="-122"/>
+                <a:cs typeface="Cambria" pitchFamily="34" charset="-120"/>
               </a:rPr>
               <a:t>HTTPS de bout en bout</a:t>
             </a:r>
@@ -6089,11 +6126,11 @@
             <a:avLst/>
           </a:prstGeom>
           <a:solidFill>
-            <a:srgbClr val="2EC4B6"/>
+            <a:srgbClr val="2E9E5B"/>
           </a:solidFill>
           <a:ln w="12700">
             <a:solidFill>
-              <a:srgbClr val="2EC4B6"/>
+              <a:srgbClr val="2E9E5B"/>
             </a:solidFill>
             <a:prstDash val="solid"/>
           </a:ln>
@@ -6152,9 +6189,9 @@
                 <a:solidFill>
                   <a:schemeClr val="tx1"/>
                 </a:solidFill>
-                <a:latin typeface="Arial" pitchFamily="34" charset="0"/>
-                <a:ea typeface="Arial" pitchFamily="34" charset="-122"/>
-                <a:cs typeface="Arial" pitchFamily="34" charset="-120"/>
+                <a:latin typeface="Cambria" pitchFamily="34" charset="0"/>
+                <a:ea typeface="Cambria" pitchFamily="34" charset="-122"/>
+                <a:cs typeface="Cambria" pitchFamily="34" charset="-120"/>
               </a:rPr>
               <a:t>Multi-sites</a:t>
             </a:r>
@@ -6302,9 +6339,9 @@
                 <a:solidFill>
                   <a:schemeClr val="bg1"/>
                 </a:solidFill>
-                <a:latin typeface="Arial" pitchFamily="34" charset="0"/>
-                <a:ea typeface="Arial" pitchFamily="34" charset="-122"/>
-                <a:cs typeface="Arial" pitchFamily="34" charset="-120"/>
+                <a:latin typeface="Cambria" pitchFamily="34" charset="0"/>
+                <a:ea typeface="Cambria" pitchFamily="34" charset="-122"/>
+                <a:cs typeface="Cambria" pitchFamily="34" charset="-120"/>
               </a:rPr>
               <a:t>Merci</a:t>
             </a:r>
@@ -6347,7 +6384,7 @@
                 <a:ea typeface="Calibri" pitchFamily="34" charset="-122"/>
                 <a:cs typeface="Calibri" pitchFamily="34" charset="-120"/>
               </a:rPr>
-              <a:t>Sentinel-X : la sécurité à la bordure</a:t>
+              <a:t>FORTEX · Sentinel-X : la sécurité à la bordure</a:t>
             </a:r>
             <a:endParaRPr lang="en-US" sz="2200" dirty="0"/>
           </a:p>
@@ -6368,11 +6405,11 @@
             <a:avLst/>
           </a:prstGeom>
           <a:solidFill>
-            <a:srgbClr val="1C2B3A"/>
+            <a:srgbClr val="353D44"/>
           </a:solidFill>
           <a:ln w="12700">
             <a:solidFill>
-              <a:srgbClr val="1C2B3A"/>
+              <a:srgbClr val="353D44"/>
             </a:solidFill>
             <a:prstDash val="solid"/>
           </a:ln>
@@ -6536,11 +6573,11 @@
                 <a:solidFill>
                   <a:schemeClr val="tx1"/>
                 </a:solidFill>
-                <a:latin typeface="Arial" pitchFamily="34" charset="0"/>
-                <a:ea typeface="Arial" pitchFamily="34" charset="-122"/>
-                <a:cs typeface="Arial" pitchFamily="34" charset="-120"/>
-              </a:rPr>
-              <a:t>Un consortium de quatre filières</a:t>
+                <a:latin typeface="Cambria" pitchFamily="34" charset="0"/>
+                <a:ea typeface="Cambria" pitchFamily="34" charset="-122"/>
+                <a:cs typeface="Cambria" pitchFamily="34" charset="-120"/>
+              </a:rPr>
+              <a:t>Projet FORTEX : cinq ingénieurs, quatre filières</a:t>
             </a:r>
             <a:endParaRPr lang="en-US" sz="3400" dirty="0"/>
           </a:p>
@@ -6548,26 +6585,26 @@
       </p:sp>
       <p:sp>
         <p:nvSpPr>
-          <p:cNvPr id="3" name="Carte DEV"/>
+          <p:cNvPr id="3" name="Carte Kephren BIBANG"/>
           <p:cNvSpPr/>
           <p:nvPr/>
         </p:nvSpPr>
         <p:spPr>
           <a:xfrm>
-            <a:off x="548640" y="1463040"/>
-            <a:ext cx="2606040" cy="3657600"/>
+            <a:off x="548640" y="1417320"/>
+            <a:ext cx="2075688" cy="4160520"/>
           </a:xfrm>
           <a:prstGeom prst="roundRect">
             <a:avLst>
-              <a:gd name="adj" fmla="val 4211"/>
+              <a:gd name="adj" fmla="val 5286"/>
             </a:avLst>
           </a:prstGeom>
           <a:solidFill>
-            <a:srgbClr val="EEF2F6"/>
+            <a:srgbClr val="EEF3F0"/>
           </a:solidFill>
           <a:ln w="12700">
             <a:solidFill>
-              <a:srgbClr val="EEF2F6"/>
+              <a:srgbClr val="EEF3F0"/>
             </a:solidFill>
             <a:prstDash val="solid"/>
           </a:ln>
@@ -6575,24 +6612,24 @@
       </p:sp>
       <p:sp>
         <p:nvSpPr>
-          <p:cNvPr id="4" name="Icone DEV fond"/>
+          <p:cNvPr id="4" name="Icone Kephren BIBANG fond"/>
           <p:cNvSpPr/>
           <p:nvPr/>
         </p:nvSpPr>
         <p:spPr>
           <a:xfrm>
-            <a:off x="1325880" y="1783080"/>
-            <a:ext cx="1051560" cy="1051560"/>
+            <a:off x="1124712" y="1691640"/>
+            <a:ext cx="914400" cy="914400"/>
           </a:xfrm>
           <a:prstGeom prst="ellipse">
             <a:avLst/>
           </a:prstGeom>
           <a:solidFill>
-            <a:srgbClr val="5B8DEF"/>
+            <a:srgbClr val="1F6B42"/>
           </a:solidFill>
           <a:ln w="12700">
             <a:solidFill>
-              <a:srgbClr val="5B8DEF"/>
+              <a:srgbClr val="1F6B42"/>
             </a:solidFill>
             <a:prstDash val="solid"/>
           </a:ln>
@@ -6600,7 +6637,7 @@
       </p:sp>
       <p:pic>
         <p:nvPicPr>
-          <p:cNvPr id="5" name="Icone DEV" descr="preencoded.png">    </p:cNvPr>
+          <p:cNvPr id="5" name="Icone Kephren BIBANG" descr="preencoded.png">    </p:cNvPr>
           <p:cNvPicPr>
             <a:picLocks noChangeAspect="1"/>
           </p:cNvPicPr>
@@ -6614,8 +6651,8 @@
         </p:blipFill>
         <p:spPr>
           <a:xfrm>
-            <a:off x="1588770" y="2045970"/>
-            <a:ext cx="525780" cy="525780"/>
+            <a:off x="1353312" y="1920240"/>
+            <a:ext cx="457200" cy="457200"/>
           </a:xfrm>
           <a:prstGeom prst="rect">
             <a:avLst/>
@@ -6630,8 +6667,8 @@
         </p:nvSpPr>
         <p:spPr>
           <a:xfrm>
-            <a:off x="731520" y="3063240"/>
-            <a:ext cx="2240280" cy="457200"/>
+            <a:off x="658368" y="2743200"/>
+            <a:ext cx="1856232" cy="960120"/>
           </a:xfrm>
           <a:prstGeom prst="rect">
             <a:avLst/>
@@ -6647,17 +6684,17 @@
               <a:buNone/>
             </a:pPr>
             <a:r>
-              <a:rPr lang="en-US" sz="2000" b="1" dirty="0">
+              <a:rPr lang="en-US" sz="1600" b="1" dirty="0">
                 <a:solidFill>
                   <a:schemeClr val="tx1"/>
                 </a:solidFill>
-                <a:latin typeface="Arial" pitchFamily="34" charset="0"/>
-                <a:ea typeface="Arial" pitchFamily="34" charset="-122"/>
-                <a:cs typeface="Arial" pitchFamily="34" charset="-120"/>
-              </a:rPr>
-              <a:t>Kephren</a:t>
-            </a:r>
-            <a:endParaRPr lang="en-US" sz="2000" dirty="0"/>
+                <a:latin typeface="Cambria" pitchFamily="34" charset="0"/>
+                <a:ea typeface="Cambria" pitchFamily="34" charset="-122"/>
+                <a:cs typeface="Cambria" pitchFamily="34" charset="-120"/>
+              </a:rPr>
+              <a:t>Kephren BIBANG</a:t>
+            </a:r>
+            <a:endParaRPr lang="en-US" sz="1600" dirty="0"/>
           </a:p>
         </p:txBody>
       </p:sp>
@@ -6669,8 +6706,8 @@
         </p:nvSpPr>
         <p:spPr>
           <a:xfrm>
-            <a:off x="731520" y="3520440"/>
-            <a:ext cx="2240280" cy="365760"/>
+            <a:off x="658368" y="3749040"/>
+            <a:ext cx="1856232" cy="365760"/>
           </a:xfrm>
           <a:prstGeom prst="rect">
             <a:avLst/>
@@ -6686,9 +6723,9 @@
               <a:buNone/>
             </a:pPr>
             <a:r>
-              <a:rPr lang="en-US" sz="1600" b="1" dirty="0">
-                <a:solidFill>
-                  <a:srgbClr val="5B8DEF"/>
+              <a:rPr lang="en-US" sz="1500" b="1" dirty="0">
+                <a:solidFill>
+                  <a:srgbClr val="1F6B42"/>
                 </a:solidFill>
                 <a:latin typeface="Calibri" pitchFamily="34" charset="0"/>
                 <a:ea typeface="Calibri" pitchFamily="34" charset="-122"/>
@@ -6696,7 +6733,7 @@
               </a:rPr>
               <a:t>DEV</a:t>
             </a:r>
-            <a:endParaRPr lang="en-US" sz="1600" dirty="0"/>
+            <a:endParaRPr lang="en-US" sz="1500" dirty="0"/>
           </a:p>
         </p:txBody>
       </p:sp>
@@ -6708,8 +6745,8 @@
         </p:nvSpPr>
         <p:spPr>
           <a:xfrm>
-            <a:off x="777240" y="4069080"/>
-            <a:ext cx="2148840" cy="1280160"/>
+            <a:off x="685800" y="4206240"/>
+            <a:ext cx="1801368" cy="1188720"/>
           </a:xfrm>
           <a:prstGeom prst="rect">
             <a:avLst/>
@@ -6741,26 +6778,26 @@
       </p:sp>
       <p:sp>
         <p:nvSpPr>
-          <p:cNvPr id="9" name="Carte IA &amp; Data"/>
+          <p:cNvPr id="9" name="Carte Mamadou SECK"/>
           <p:cNvSpPr/>
           <p:nvPr/>
         </p:nvSpPr>
         <p:spPr>
           <a:xfrm>
-            <a:off x="3364992" y="1463040"/>
-            <a:ext cx="2606040" cy="3657600"/>
+            <a:off x="2807208" y="1417320"/>
+            <a:ext cx="2075688" cy="4160520"/>
           </a:xfrm>
           <a:prstGeom prst="roundRect">
             <a:avLst>
-              <a:gd name="adj" fmla="val 4211"/>
+              <a:gd name="adj" fmla="val 5286"/>
             </a:avLst>
           </a:prstGeom>
           <a:solidFill>
-            <a:srgbClr val="EEF2F6"/>
+            <a:srgbClr val="EEF3F0"/>
           </a:solidFill>
           <a:ln w="12700">
             <a:solidFill>
-              <a:srgbClr val="EEF2F6"/>
+              <a:srgbClr val="EEF3F0"/>
             </a:solidFill>
             <a:prstDash val="solid"/>
           </a:ln>
@@ -6768,24 +6805,24 @@
       </p:sp>
       <p:sp>
         <p:nvSpPr>
-          <p:cNvPr id="10" name="Icone IA &amp; Data fond"/>
+          <p:cNvPr id="10" name="Icone Mamadou SECK fond"/>
           <p:cNvSpPr/>
           <p:nvPr/>
         </p:nvSpPr>
         <p:spPr>
           <a:xfrm>
-            <a:off x="4142232" y="1783080"/>
-            <a:ext cx="1051560" cy="1051560"/>
+            <a:off x="3383280" y="1691640"/>
+            <a:ext cx="914400" cy="914400"/>
           </a:xfrm>
           <a:prstGeom prst="ellipse">
             <a:avLst/>
           </a:prstGeom>
           <a:solidFill>
-            <a:srgbClr val="FF8A3D"/>
+            <a:srgbClr val="2E9E5B"/>
           </a:solidFill>
           <a:ln w="12700">
             <a:solidFill>
-              <a:srgbClr val="FF8A3D"/>
+              <a:srgbClr val="2E9E5B"/>
             </a:solidFill>
             <a:prstDash val="solid"/>
           </a:ln>
@@ -6793,7 +6830,7 @@
       </p:sp>
       <p:pic>
         <p:nvPicPr>
-          <p:cNvPr id="11" name="Icone IA &amp; Data" descr="preencoded.png">    </p:cNvPr>
+          <p:cNvPr id="11" name="Icone Mamadou SECK" descr="preencoded.png">    </p:cNvPr>
           <p:cNvPicPr>
             <a:picLocks noChangeAspect="1"/>
           </p:cNvPicPr>
@@ -6807,8 +6844,8 @@
         </p:blipFill>
         <p:spPr>
           <a:xfrm>
-            <a:off x="4405122" y="2045970"/>
-            <a:ext cx="525780" cy="525780"/>
+            <a:off x="3611880" y="1920240"/>
+            <a:ext cx="457200" cy="457200"/>
           </a:xfrm>
           <a:prstGeom prst="rect">
             <a:avLst/>
@@ -6823,8 +6860,8 @@
         </p:nvSpPr>
         <p:spPr>
           <a:xfrm>
-            <a:off x="3547872" y="3063240"/>
-            <a:ext cx="2240280" cy="457200"/>
+            <a:off x="2916936" y="2743200"/>
+            <a:ext cx="1856232" cy="960120"/>
           </a:xfrm>
           <a:prstGeom prst="rect">
             <a:avLst/>
@@ -6840,17 +6877,17 @@
               <a:buNone/>
             </a:pPr>
             <a:r>
-              <a:rPr lang="en-US" sz="2000" b="1" dirty="0">
+              <a:rPr lang="en-US" sz="1600" b="1" dirty="0">
                 <a:solidFill>
                   <a:schemeClr val="tx1"/>
                 </a:solidFill>
-                <a:latin typeface="Arial" pitchFamily="34" charset="0"/>
-                <a:ea typeface="Arial" pitchFamily="34" charset="-122"/>
-                <a:cs typeface="Arial" pitchFamily="34" charset="-120"/>
+                <a:latin typeface="Cambria" pitchFamily="34" charset="0"/>
+                <a:ea typeface="Cambria" pitchFamily="34" charset="-122"/>
+                <a:cs typeface="Cambria" pitchFamily="34" charset="-120"/>
               </a:rPr>
               <a:t>Mamadou SECK</a:t>
             </a:r>
-            <a:endParaRPr lang="en-US" sz="2000" dirty="0"/>
+            <a:endParaRPr lang="en-US" sz="1600" dirty="0"/>
           </a:p>
         </p:txBody>
       </p:sp>
@@ -6862,8 +6899,8 @@
         </p:nvSpPr>
         <p:spPr>
           <a:xfrm>
-            <a:off x="3547872" y="3520440"/>
-            <a:ext cx="2240280" cy="365760"/>
+            <a:off x="2916936" y="3749040"/>
+            <a:ext cx="1856232" cy="365760"/>
           </a:xfrm>
           <a:prstGeom prst="rect">
             <a:avLst/>
@@ -6879,9 +6916,9 @@
               <a:buNone/>
             </a:pPr>
             <a:r>
-              <a:rPr lang="en-US" sz="1600" b="1" dirty="0">
-                <a:solidFill>
-                  <a:srgbClr val="FF8A3D"/>
+              <a:rPr lang="en-US" sz="1500" b="1" dirty="0">
+                <a:solidFill>
+                  <a:srgbClr val="2E9E5B"/>
                 </a:solidFill>
                 <a:latin typeface="Calibri" pitchFamily="34" charset="0"/>
                 <a:ea typeface="Calibri" pitchFamily="34" charset="-122"/>
@@ -6889,7 +6926,7 @@
               </a:rPr>
               <a:t>IA &amp; Data</a:t>
             </a:r>
-            <a:endParaRPr lang="en-US" sz="1600" dirty="0"/>
+            <a:endParaRPr lang="en-US" sz="1500" dirty="0"/>
           </a:p>
         </p:txBody>
       </p:sp>
@@ -6901,8 +6938,8 @@
         </p:nvSpPr>
         <p:spPr>
           <a:xfrm>
-            <a:off x="3593592" y="4069080"/>
-            <a:ext cx="2148840" cy="1280160"/>
+            <a:off x="2944368" y="4206240"/>
+            <a:ext cx="1801368" cy="1188720"/>
           </a:xfrm>
           <a:prstGeom prst="rect">
             <a:avLst/>
@@ -6926,7 +6963,7 @@
                 <a:ea typeface="Calibri" pitchFamily="34" charset="-122"/>
                 <a:cs typeface="Calibri" pitchFamily="34" charset="-120"/>
               </a:rPr>
-              <a:t>Vision YOLOv8, maintenance prédictive, backend</a:t>
+              <a:t>Vision YOLOv8, IA prédictive, backend</a:t>
             </a:r>
             <a:endParaRPr lang="en-US" sz="1400" dirty="0"/>
           </a:p>
@@ -6934,26 +6971,26 @@
       </p:sp>
       <p:sp>
         <p:nvSpPr>
-          <p:cNvPr id="15" name="Carte INFRA"/>
+          <p:cNvPr id="15" name="Carte Arsene Arayi Mbengue"/>
           <p:cNvSpPr/>
           <p:nvPr/>
         </p:nvSpPr>
         <p:spPr>
           <a:xfrm>
-            <a:off x="6181344" y="1463040"/>
-            <a:ext cx="2606040" cy="3657600"/>
+            <a:off x="5065776" y="1417320"/>
+            <a:ext cx="2075688" cy="4160520"/>
           </a:xfrm>
           <a:prstGeom prst="roundRect">
             <a:avLst>
-              <a:gd name="adj" fmla="val 4211"/>
+              <a:gd name="adj" fmla="val 5286"/>
             </a:avLst>
           </a:prstGeom>
           <a:solidFill>
-            <a:srgbClr val="EEF2F6"/>
+            <a:srgbClr val="EEF3F0"/>
           </a:solidFill>
           <a:ln w="12700">
             <a:solidFill>
-              <a:srgbClr val="EEF2F6"/>
+              <a:srgbClr val="EEF3F0"/>
             </a:solidFill>
             <a:prstDash val="solid"/>
           </a:ln>
@@ -6961,24 +6998,24 @@
       </p:sp>
       <p:sp>
         <p:nvSpPr>
-          <p:cNvPr id="16" name="Icone INFRA fond"/>
+          <p:cNvPr id="16" name="Icone Arsene Arayi Mbengue fond"/>
           <p:cNvSpPr/>
           <p:nvPr/>
         </p:nvSpPr>
         <p:spPr>
           <a:xfrm>
-            <a:off x="6958584" y="1783080"/>
-            <a:ext cx="1051560" cy="1051560"/>
+            <a:off x="5641848" y="1691640"/>
+            <a:ext cx="914400" cy="914400"/>
           </a:xfrm>
           <a:prstGeom prst="ellipse">
             <a:avLst/>
           </a:prstGeom>
           <a:solidFill>
-            <a:srgbClr val="2EC4B6"/>
+            <a:srgbClr val="2E9E5B"/>
           </a:solidFill>
           <a:ln w="12700">
             <a:solidFill>
-              <a:srgbClr val="2EC4B6"/>
+              <a:srgbClr val="2E9E5B"/>
             </a:solidFill>
             <a:prstDash val="solid"/>
           </a:ln>
@@ -6986,7 +7023,7 @@
       </p:sp>
       <p:pic>
         <p:nvPicPr>
-          <p:cNvPr id="17" name="Icone INFRA" descr="preencoded.png">    </p:cNvPr>
+          <p:cNvPr id="17" name="Icone Arsene Arayi Mbengue" descr="preencoded.png">    </p:cNvPr>
           <p:cNvPicPr>
             <a:picLocks noChangeAspect="1"/>
           </p:cNvPicPr>
@@ -7000,8 +7037,8 @@
         </p:blipFill>
         <p:spPr>
           <a:xfrm>
-            <a:off x="7221474" y="2045970"/>
-            <a:ext cx="525780" cy="525780"/>
+            <a:off x="5870448" y="1920240"/>
+            <a:ext cx="457200" cy="457200"/>
           </a:xfrm>
           <a:prstGeom prst="rect">
             <a:avLst/>
@@ -7016,8 +7053,8 @@
         </p:nvSpPr>
         <p:spPr>
           <a:xfrm>
-            <a:off x="6364224" y="3063240"/>
-            <a:ext cx="2240280" cy="457200"/>
+            <a:off x="5175504" y="2743200"/>
+            <a:ext cx="1856232" cy="960120"/>
           </a:xfrm>
           <a:prstGeom prst="rect">
             <a:avLst/>
@@ -7033,17 +7070,17 @@
               <a:buNone/>
             </a:pPr>
             <a:r>
-              <a:rPr lang="en-US" sz="2000" b="1" dirty="0">
+              <a:rPr lang="en-US" sz="1600" b="1" dirty="0">
                 <a:solidFill>
                   <a:schemeClr val="tx1"/>
                 </a:solidFill>
-                <a:latin typeface="Arial" pitchFamily="34" charset="0"/>
-                <a:ea typeface="Arial" pitchFamily="34" charset="-122"/>
-                <a:cs typeface="Arial" pitchFamily="34" charset="-120"/>
-              </a:rPr>
-              <a:t>Ismahel</a:t>
-            </a:r>
-            <a:endParaRPr lang="en-US" sz="2000" dirty="0"/>
+                <a:latin typeface="Cambria" pitchFamily="34" charset="0"/>
+                <a:ea typeface="Cambria" pitchFamily="34" charset="-122"/>
+                <a:cs typeface="Cambria" pitchFamily="34" charset="-120"/>
+              </a:rPr>
+              <a:t>Arsene Arayi Mbengue</a:t>
+            </a:r>
+            <a:endParaRPr lang="en-US" sz="1600" dirty="0"/>
           </a:p>
         </p:txBody>
       </p:sp>
@@ -7055,8 +7092,8 @@
         </p:nvSpPr>
         <p:spPr>
           <a:xfrm>
-            <a:off x="6364224" y="3520440"/>
-            <a:ext cx="2240280" cy="365760"/>
+            <a:off x="5175504" y="3749040"/>
+            <a:ext cx="1856232" cy="365760"/>
           </a:xfrm>
           <a:prstGeom prst="rect">
             <a:avLst/>
@@ -7072,17 +7109,17 @@
               <a:buNone/>
             </a:pPr>
             <a:r>
-              <a:rPr lang="en-US" sz="1600" b="1" dirty="0">
-                <a:solidFill>
-                  <a:srgbClr val="2EC4B6"/>
+              <a:rPr lang="en-US" sz="1500" b="1" dirty="0">
+                <a:solidFill>
+                  <a:srgbClr val="2E9E5B"/>
                 </a:solidFill>
                 <a:latin typeface="Calibri" pitchFamily="34" charset="0"/>
                 <a:ea typeface="Calibri" pitchFamily="34" charset="-122"/>
                 <a:cs typeface="Calibri" pitchFamily="34" charset="-120"/>
               </a:rPr>
-              <a:t>INFRA</a:t>
-            </a:r>
-            <a:endParaRPr lang="en-US" sz="1600" dirty="0"/>
+              <a:t>IA &amp; Data</a:t>
+            </a:r>
+            <a:endParaRPr lang="en-US" sz="1500" dirty="0"/>
           </a:p>
         </p:txBody>
       </p:sp>
@@ -7094,8 +7131,8 @@
         </p:nvSpPr>
         <p:spPr>
           <a:xfrm>
-            <a:off x="6409944" y="4069080"/>
-            <a:ext cx="2148840" cy="1280160"/>
+            <a:off x="5202936" y="4206240"/>
+            <a:ext cx="1801368" cy="1188720"/>
           </a:xfrm>
           <a:prstGeom prst="rect">
             <a:avLst/>
@@ -7119,7 +7156,7 @@
                 <a:ea typeface="Calibri" pitchFamily="34" charset="-122"/>
                 <a:cs typeface="Calibri" pitchFamily="34" charset="-120"/>
               </a:rPr>
-              <a:t>Docker Compose, MQTT, PostgreSQL, réseau</a:t>
+              <a:t>Intelligence artificielle et données</a:t>
             </a:r>
             <a:endParaRPr lang="en-US" sz="1400" dirty="0"/>
           </a:p>
@@ -7127,26 +7164,26 @@
       </p:sp>
       <p:sp>
         <p:nvSpPr>
-          <p:cNvPr id="21" name="Carte CYBER"/>
+          <p:cNvPr id="21" name="Carte Toure Ismahel Ousmane Losseni Junior"/>
           <p:cNvSpPr/>
           <p:nvPr/>
         </p:nvSpPr>
         <p:spPr>
           <a:xfrm>
-            <a:off x="8997696" y="1463040"/>
-            <a:ext cx="2606040" cy="3657600"/>
+            <a:off x="7324344" y="1417320"/>
+            <a:ext cx="2075688" cy="4160520"/>
           </a:xfrm>
           <a:prstGeom prst="roundRect">
             <a:avLst>
-              <a:gd name="adj" fmla="val 4211"/>
+              <a:gd name="adj" fmla="val 5286"/>
             </a:avLst>
           </a:prstGeom>
           <a:solidFill>
-            <a:srgbClr val="EEF2F6"/>
+            <a:srgbClr val="EEF3F0"/>
           </a:solidFill>
           <a:ln w="12700">
             <a:solidFill>
-              <a:srgbClr val="EEF2F6"/>
+              <a:srgbClr val="EEF3F0"/>
             </a:solidFill>
             <a:prstDash val="solid"/>
           </a:ln>
@@ -7154,24 +7191,24 @@
       </p:sp>
       <p:sp>
         <p:nvSpPr>
-          <p:cNvPr id="22" name="Icone CYBER fond"/>
+          <p:cNvPr id="22" name="Icone Toure Ismahel Ousmane Losseni Junior fond"/>
           <p:cNvSpPr/>
           <p:nvPr/>
         </p:nvSpPr>
         <p:spPr>
           <a:xfrm>
-            <a:off x="9774936" y="1783080"/>
-            <a:ext cx="1051560" cy="1051560"/>
+            <a:off x="7900416" y="1691640"/>
+            <a:ext cx="914400" cy="914400"/>
           </a:xfrm>
           <a:prstGeom prst="ellipse">
             <a:avLst/>
           </a:prstGeom>
           <a:solidFill>
-            <a:srgbClr val="E63946"/>
+            <a:srgbClr val="3A8F86"/>
           </a:solidFill>
           <a:ln w="12700">
             <a:solidFill>
-              <a:srgbClr val="E63946"/>
+              <a:srgbClr val="3A8F86"/>
             </a:solidFill>
             <a:prstDash val="solid"/>
           </a:ln>
@@ -7179,7 +7216,7 @@
       </p:sp>
       <p:pic>
         <p:nvPicPr>
-          <p:cNvPr id="23" name="Icone CYBER" descr="preencoded.png">    </p:cNvPr>
+          <p:cNvPr id="23" name="Icone Toure Ismahel Ousmane Losseni Junior" descr="preencoded.png">    </p:cNvPr>
           <p:cNvPicPr>
             <a:picLocks noChangeAspect="1"/>
           </p:cNvPicPr>
@@ -7193,8 +7230,8 @@
         </p:blipFill>
         <p:spPr>
           <a:xfrm>
-            <a:off x="10037826" y="2045970"/>
-            <a:ext cx="525780" cy="525780"/>
+            <a:off x="8129016" y="1920240"/>
+            <a:ext cx="457200" cy="457200"/>
           </a:xfrm>
           <a:prstGeom prst="rect">
             <a:avLst/>
@@ -7209,8 +7246,8 @@
         </p:nvSpPr>
         <p:spPr>
           <a:xfrm>
-            <a:off x="9180576" y="3063240"/>
-            <a:ext cx="2240280" cy="457200"/>
+            <a:off x="7434072" y="2743200"/>
+            <a:ext cx="1856232" cy="960120"/>
           </a:xfrm>
           <a:prstGeom prst="rect">
             <a:avLst/>
@@ -7226,17 +7263,17 @@
               <a:buNone/>
             </a:pPr>
             <a:r>
-              <a:rPr lang="en-US" sz="2000" b="1" dirty="0">
+              <a:rPr lang="en-US" sz="1600" b="1" dirty="0">
                 <a:solidFill>
                   <a:schemeClr val="tx1"/>
                 </a:solidFill>
-                <a:latin typeface="Arial" pitchFamily="34" charset="0"/>
-                <a:ea typeface="Arial" pitchFamily="34" charset="-122"/>
-                <a:cs typeface="Arial" pitchFamily="34" charset="-120"/>
-              </a:rPr>
-              <a:t>[Nom]</a:t>
-            </a:r>
-            <a:endParaRPr lang="en-US" sz="2000" dirty="0"/>
+                <a:latin typeface="Cambria" pitchFamily="34" charset="0"/>
+                <a:ea typeface="Cambria" pitchFamily="34" charset="-122"/>
+                <a:cs typeface="Cambria" pitchFamily="34" charset="-120"/>
+              </a:rPr>
+              <a:t>Toure Ismahel Ousmane Losseni Junior</a:t>
+            </a:r>
+            <a:endParaRPr lang="en-US" sz="1600" dirty="0"/>
           </a:p>
         </p:txBody>
       </p:sp>
@@ -7248,8 +7285,8 @@
         </p:nvSpPr>
         <p:spPr>
           <a:xfrm>
-            <a:off x="9180576" y="3520440"/>
-            <a:ext cx="2240280" cy="365760"/>
+            <a:off x="7434072" y="3749040"/>
+            <a:ext cx="1856232" cy="365760"/>
           </a:xfrm>
           <a:prstGeom prst="rect">
             <a:avLst/>
@@ -7265,17 +7302,17 @@
               <a:buNone/>
             </a:pPr>
             <a:r>
-              <a:rPr lang="en-US" sz="1600" b="1" dirty="0">
-                <a:solidFill>
-                  <a:srgbClr val="E63946"/>
+              <a:rPr lang="en-US" sz="1500" b="1" dirty="0">
+                <a:solidFill>
+                  <a:srgbClr val="3A8F86"/>
                 </a:solidFill>
                 <a:latin typeface="Calibri" pitchFamily="34" charset="0"/>
                 <a:ea typeface="Calibri" pitchFamily="34" charset="-122"/>
                 <a:cs typeface="Calibri" pitchFamily="34" charset="-120"/>
               </a:rPr>
-              <a:t>CYBER</a:t>
-            </a:r>
-            <a:endParaRPr lang="en-US" sz="1600" dirty="0"/>
+              <a:t>INFRA</a:t>
+            </a:r>
+            <a:endParaRPr lang="en-US" sz="1500" dirty="0"/>
           </a:p>
         </p:txBody>
       </p:sp>
@@ -7287,8 +7324,201 @@
         </p:nvSpPr>
         <p:spPr>
           <a:xfrm>
-            <a:off x="9226296" y="4069080"/>
-            <a:ext cx="2148840" cy="1280160"/>
+            <a:off x="7461504" y="4206240"/>
+            <a:ext cx="1801368" cy="1188720"/>
+          </a:xfrm>
+          <a:prstGeom prst="rect">
+            <a:avLst/>
+          </a:prstGeom>
+          <a:noFill/>
+          <a:ln/>
+        </p:spPr>
+        <p:txBody>
+          <a:bodyPr wrap="square" lIns="0" tIns="0" rIns="0" bIns="0" rtlCol="0" anchor="t"/>
+          <a:lstStyle/>
+          <a:p>
+            <a:pPr algn="ctr" indent="0" marL="0">
+              <a:buNone/>
+            </a:pPr>
+            <a:r>
+              <a:rPr lang="en-US" sz="1400" dirty="0">
+                <a:solidFill>
+                  <a:schemeClr val="tx2"/>
+                </a:solidFill>
+                <a:latin typeface="Calibri" pitchFamily="34" charset="0"/>
+                <a:ea typeface="Calibri" pitchFamily="34" charset="-122"/>
+                <a:cs typeface="Calibri" pitchFamily="34" charset="-120"/>
+              </a:rPr>
+              <a:t>Docker Compose, MQTT, PostgreSQL, réseau</a:t>
+            </a:r>
+            <a:endParaRPr lang="en-US" sz="1400" dirty="0"/>
+          </a:p>
+        </p:txBody>
+      </p:sp>
+      <p:sp>
+        <p:nvSpPr>
+          <p:cNvPr id="27" name="Carte Raoly KOUMOU"/>
+          <p:cNvSpPr/>
+          <p:nvPr/>
+        </p:nvSpPr>
+        <p:spPr>
+          <a:xfrm>
+            <a:off x="9582912" y="1417320"/>
+            <a:ext cx="2075688" cy="4160520"/>
+          </a:xfrm>
+          <a:prstGeom prst="roundRect">
+            <a:avLst>
+              <a:gd name="adj" fmla="val 5286"/>
+            </a:avLst>
+          </a:prstGeom>
+          <a:solidFill>
+            <a:srgbClr val="EEF3F0"/>
+          </a:solidFill>
+          <a:ln w="12700">
+            <a:solidFill>
+              <a:srgbClr val="EEF3F0"/>
+            </a:solidFill>
+            <a:prstDash val="solid"/>
+          </a:ln>
+        </p:spPr>
+      </p:sp>
+      <p:sp>
+        <p:nvSpPr>
+          <p:cNvPr id="28" name="Icone Raoly KOUMOU fond"/>
+          <p:cNvSpPr/>
+          <p:nvPr/>
+        </p:nvSpPr>
+        <p:spPr>
+          <a:xfrm>
+            <a:off x="10158984" y="1691640"/>
+            <a:ext cx="914400" cy="914400"/>
+          </a:xfrm>
+          <a:prstGeom prst="ellipse">
+            <a:avLst/>
+          </a:prstGeom>
+          <a:solidFill>
+            <a:srgbClr val="D64545"/>
+          </a:solidFill>
+          <a:ln w="12700">
+            <a:solidFill>
+              <a:srgbClr val="D64545"/>
+            </a:solidFill>
+            <a:prstDash val="solid"/>
+          </a:ln>
+        </p:spPr>
+      </p:sp>
+      <p:pic>
+        <p:nvPicPr>
+          <p:cNvPr id="29" name="Icone Raoly KOUMOU" descr="preencoded.png">    </p:cNvPr>
+          <p:cNvPicPr>
+            <a:picLocks noChangeAspect="1"/>
+          </p:cNvPicPr>
+          <p:nvPr/>
+        </p:nvPicPr>
+        <p:blipFill>
+          <a:blip r:embed="rId5"/>
+          <a:stretch>
+            <a:fillRect/>
+          </a:stretch>
+        </p:blipFill>
+        <p:spPr>
+          <a:xfrm>
+            <a:off x="10387584" y="1920240"/>
+            <a:ext cx="457200" cy="457200"/>
+          </a:xfrm>
+          <a:prstGeom prst="rect">
+            <a:avLst/>
+          </a:prstGeom>
+        </p:spPr>
+      </p:pic>
+      <p:sp>
+        <p:nvSpPr>
+          <p:cNvPr id="30" name="Text 23"/>
+          <p:cNvSpPr txBox="1"/>
+          <p:nvPr/>
+        </p:nvSpPr>
+        <p:spPr>
+          <a:xfrm>
+            <a:off x="9692640" y="2743200"/>
+            <a:ext cx="1856232" cy="960120"/>
+          </a:xfrm>
+          <a:prstGeom prst="rect">
+            <a:avLst/>
+          </a:prstGeom>
+          <a:noFill/>
+          <a:ln/>
+        </p:spPr>
+        <p:txBody>
+          <a:bodyPr wrap="square" lIns="0" tIns="0" rIns="0" bIns="0" rtlCol="0" anchor="ctr"/>
+          <a:lstStyle/>
+          <a:p>
+            <a:pPr algn="ctr" indent="0" marL="0">
+              <a:buNone/>
+            </a:pPr>
+            <a:r>
+              <a:rPr lang="en-US" sz="1600" b="1" dirty="0">
+                <a:solidFill>
+                  <a:schemeClr val="tx1"/>
+                </a:solidFill>
+                <a:latin typeface="Cambria" pitchFamily="34" charset="0"/>
+                <a:ea typeface="Cambria" pitchFamily="34" charset="-122"/>
+                <a:cs typeface="Cambria" pitchFamily="34" charset="-120"/>
+              </a:rPr>
+              <a:t>Raoly KOUMOU</a:t>
+            </a:r>
+            <a:endParaRPr lang="en-US" sz="1600" dirty="0"/>
+          </a:p>
+        </p:txBody>
+      </p:sp>
+      <p:sp>
+        <p:nvSpPr>
+          <p:cNvPr id="31" name="Text 24"/>
+          <p:cNvSpPr txBox="1"/>
+          <p:nvPr/>
+        </p:nvSpPr>
+        <p:spPr>
+          <a:xfrm>
+            <a:off x="9692640" y="3749040"/>
+            <a:ext cx="1856232" cy="365760"/>
+          </a:xfrm>
+          <a:prstGeom prst="rect">
+            <a:avLst/>
+          </a:prstGeom>
+          <a:noFill/>
+          <a:ln/>
+        </p:spPr>
+        <p:txBody>
+          <a:bodyPr wrap="square" lIns="0" tIns="0" rIns="0" bIns="0" rtlCol="0" anchor="ctr"/>
+          <a:lstStyle/>
+          <a:p>
+            <a:pPr algn="ctr" indent="0" marL="0">
+              <a:buNone/>
+            </a:pPr>
+            <a:r>
+              <a:rPr lang="en-US" sz="1500" b="1" dirty="0">
+                <a:solidFill>
+                  <a:srgbClr val="D64545"/>
+                </a:solidFill>
+                <a:latin typeface="Calibri" pitchFamily="34" charset="0"/>
+                <a:ea typeface="Calibri" pitchFamily="34" charset="-122"/>
+                <a:cs typeface="Calibri" pitchFamily="34" charset="-120"/>
+              </a:rPr>
+              <a:t>CYBER</a:t>
+            </a:r>
+            <a:endParaRPr lang="en-US" sz="1500" dirty="0"/>
+          </a:p>
+        </p:txBody>
+      </p:sp>
+      <p:sp>
+        <p:nvSpPr>
+          <p:cNvPr id="32" name="Text 25"/>
+          <p:cNvSpPr txBox="1"/>
+          <p:nvPr/>
+        </p:nvSpPr>
+        <p:spPr>
+          <a:xfrm>
+            <a:off x="9720072" y="4206240"/>
+            <a:ext cx="1801368" cy="1188720"/>
           </a:xfrm>
           <a:prstGeom prst="rect">
             <a:avLst/>
@@ -7419,9 +7649,9 @@
                 <a:solidFill>
                   <a:schemeClr val="tx1"/>
                 </a:solidFill>
-                <a:latin typeface="Arial" pitchFamily="34" charset="0"/>
-                <a:ea typeface="Arial" pitchFamily="34" charset="-122"/>
-                <a:cs typeface="Arial" pitchFamily="34" charset="-120"/>
+                <a:latin typeface="Cambria" pitchFamily="34" charset="0"/>
+                <a:ea typeface="Cambria" pitchFamily="34" charset="-122"/>
+                <a:cs typeface="Cambria" pitchFamily="34" charset="-120"/>
               </a:rPr>
               <a:t>Trois menaces sur des centrales sans personnel</a:t>
             </a:r>
@@ -7485,11 +7715,11 @@
             </a:avLst>
           </a:prstGeom>
           <a:solidFill>
-            <a:srgbClr val="EEF2F6"/>
+            <a:srgbClr val="EEF3F0"/>
           </a:solidFill>
           <a:ln w="12700">
             <a:solidFill>
-              <a:srgbClr val="EEF2F6"/>
+              <a:srgbClr val="EEF3F0"/>
             </a:solidFill>
             <a:prstDash val="solid"/>
           </a:ln>
@@ -7510,11 +7740,11 @@
             <a:avLst/>
           </a:prstGeom>
           <a:solidFill>
-            <a:srgbClr val="E63946"/>
+            <a:srgbClr val="D64545"/>
           </a:solidFill>
           <a:ln w="12700">
             <a:solidFill>
-              <a:srgbClr val="E63946"/>
+              <a:srgbClr val="D64545"/>
             </a:solidFill>
             <a:prstDash val="solid"/>
           </a:ln>
@@ -7573,9 +7803,9 @@
                 <a:solidFill>
                   <a:schemeClr val="tx1"/>
                 </a:solidFill>
-                <a:latin typeface="Arial" pitchFamily="34" charset="0"/>
-                <a:ea typeface="Arial" pitchFamily="34" charset="-122"/>
-                <a:cs typeface="Arial" pitchFamily="34" charset="-120"/>
+                <a:latin typeface="Cambria" pitchFamily="34" charset="0"/>
+                <a:ea typeface="Cambria" pitchFamily="34" charset="-122"/>
+                <a:cs typeface="Cambria" pitchFamily="34" charset="-120"/>
               </a:rPr>
               <a:t>Intrusion physique</a:t>
             </a:r>
@@ -7639,11 +7869,11 @@
             </a:avLst>
           </a:prstGeom>
           <a:solidFill>
-            <a:srgbClr val="EEF2F6"/>
+            <a:srgbClr val="EEF3F0"/>
           </a:solidFill>
           <a:ln w="12700">
             <a:solidFill>
-              <a:srgbClr val="EEF2F6"/>
+              <a:srgbClr val="EEF3F0"/>
             </a:solidFill>
             <a:prstDash val="solid"/>
           </a:ln>
@@ -7664,11 +7894,11 @@
             <a:avLst/>
           </a:prstGeom>
           <a:solidFill>
-            <a:srgbClr val="FF8A3D"/>
+            <a:srgbClr val="F2B84B"/>
           </a:solidFill>
           <a:ln w="12700">
             <a:solidFill>
-              <a:srgbClr val="FF8A3D"/>
+              <a:srgbClr val="F2B84B"/>
             </a:solidFill>
             <a:prstDash val="solid"/>
           </a:ln>
@@ -7727,9 +7957,9 @@
                 <a:solidFill>
                   <a:schemeClr val="tx1"/>
                 </a:solidFill>
-                <a:latin typeface="Arial" pitchFamily="34" charset="0"/>
-                <a:ea typeface="Arial" pitchFamily="34" charset="-122"/>
-                <a:cs typeface="Arial" pitchFamily="34" charset="-120"/>
+                <a:latin typeface="Cambria" pitchFamily="34" charset="0"/>
+                <a:ea typeface="Cambria" pitchFamily="34" charset="-122"/>
+                <a:cs typeface="Cambria" pitchFamily="34" charset="-120"/>
               </a:rPr>
               <a:t>Environnement</a:t>
             </a:r>
@@ -7793,11 +8023,11 @@
             </a:avLst>
           </a:prstGeom>
           <a:solidFill>
-            <a:srgbClr val="EEF2F6"/>
+            <a:srgbClr val="EEF3F0"/>
           </a:solidFill>
           <a:ln w="12700">
             <a:solidFill>
-              <a:srgbClr val="EEF2F6"/>
+              <a:srgbClr val="EEF3F0"/>
             </a:solidFill>
             <a:prstDash val="solid"/>
           </a:ln>
@@ -7818,11 +8048,11 @@
             <a:avLst/>
           </a:prstGeom>
           <a:solidFill>
-            <a:srgbClr val="5B8DEF"/>
+            <a:srgbClr val="1F6B42"/>
           </a:solidFill>
           <a:ln w="12700">
             <a:solidFill>
-              <a:srgbClr val="5B8DEF"/>
+              <a:srgbClr val="1F6B42"/>
             </a:solidFill>
             <a:prstDash val="solid"/>
           </a:ln>
@@ -7881,9 +8111,9 @@
                 <a:solidFill>
                   <a:schemeClr val="tx1"/>
                 </a:solidFill>
-                <a:latin typeface="Arial" pitchFamily="34" charset="0"/>
-                <a:ea typeface="Arial" pitchFamily="34" charset="-122"/>
-                <a:cs typeface="Arial" pitchFamily="34" charset="-120"/>
+                <a:latin typeface="Cambria" pitchFamily="34" charset="0"/>
+                <a:ea typeface="Cambria" pitchFamily="34" charset="-122"/>
+                <a:cs typeface="Cambria" pitchFamily="34" charset="-120"/>
               </a:rPr>
               <a:t>Cyberattaque</a:t>
             </a:r>
@@ -8031,9 +8261,9 @@
                 <a:solidFill>
                   <a:schemeClr val="tx1"/>
                 </a:solidFill>
-                <a:latin typeface="Arial" pitchFamily="34" charset="0"/>
-                <a:ea typeface="Arial" pitchFamily="34" charset="-122"/>
-                <a:cs typeface="Arial" pitchFamily="34" charset="-120"/>
+                <a:latin typeface="Cambria" pitchFamily="34" charset="0"/>
+                <a:ea typeface="Cambria" pitchFamily="34" charset="-122"/>
+                <a:cs typeface="Cambria" pitchFamily="34" charset="-120"/>
               </a:rPr>
               <a:t>Notre solution : de la mesure à l'alarme, chiffré</a:t>
             </a:r>
@@ -8058,11 +8288,11 @@
             </a:avLst>
           </a:prstGeom>
           <a:solidFill>
-            <a:srgbClr val="5B8DEF"/>
+            <a:srgbClr val="1F6B42"/>
           </a:solidFill>
           <a:ln w="12700">
             <a:solidFill>
-              <a:srgbClr val="5B8DEF"/>
+              <a:srgbClr val="1F6B42"/>
             </a:solidFill>
             <a:prstDash val="solid"/>
           </a:ln>
@@ -8097,9 +8327,9 @@
                 <a:solidFill>
                   <a:schemeClr val="bg1"/>
                 </a:solidFill>
-                <a:latin typeface="Arial" pitchFamily="34" charset="0"/>
-                <a:ea typeface="Arial" pitchFamily="34" charset="-122"/>
-                <a:cs typeface="Arial" pitchFamily="34" charset="-120"/>
+                <a:latin typeface="Cambria" pitchFamily="34" charset="0"/>
+                <a:ea typeface="Cambria" pitchFamily="34" charset="-122"/>
+                <a:cs typeface="Cambria" pitchFamily="34" charset="-120"/>
               </a:rPr>
               <a:t>Boîtier ESP8266</a:t>
             </a:r>
@@ -8180,11 +8410,11 @@
             </a:avLst>
           </a:prstGeom>
           <a:solidFill>
-            <a:srgbClr val="5B8DEF"/>
+            <a:srgbClr val="1F6B42"/>
           </a:solidFill>
           <a:ln w="12700">
             <a:solidFill>
-              <a:srgbClr val="5B8DEF"/>
+              <a:srgbClr val="1F6B42"/>
             </a:solidFill>
             <a:prstDash val="solid"/>
           </a:ln>
@@ -8219,9 +8449,9 @@
                 <a:solidFill>
                   <a:schemeClr val="bg1"/>
                 </a:solidFill>
-                <a:latin typeface="Arial" pitchFamily="34" charset="0"/>
-                <a:ea typeface="Arial" pitchFamily="34" charset="-122"/>
-                <a:cs typeface="Arial" pitchFamily="34" charset="-120"/>
+                <a:latin typeface="Cambria" pitchFamily="34" charset="0"/>
+                <a:ea typeface="Cambria" pitchFamily="34" charset="-122"/>
+                <a:cs typeface="Cambria" pitchFamily="34" charset="-120"/>
               </a:rPr>
               <a:t>Webcam USB</a:t>
             </a:r>
@@ -8285,11 +8515,11 @@
             </a:avLst>
           </a:prstGeom>
           <a:solidFill>
-            <a:srgbClr val="2EC4B6"/>
+            <a:srgbClr val="3A8F86"/>
           </a:solidFill>
           <a:ln w="12700">
             <a:solidFill>
-              <a:srgbClr val="2EC4B6"/>
+              <a:srgbClr val="3A8F86"/>
             </a:solidFill>
             <a:prstDash val="solid"/>
           </a:ln>
@@ -8324,9 +8554,9 @@
                 <a:solidFill>
                   <a:schemeClr val="bg1"/>
                 </a:solidFill>
-                <a:latin typeface="Arial" pitchFamily="34" charset="0"/>
-                <a:ea typeface="Arial" pitchFamily="34" charset="-122"/>
-                <a:cs typeface="Arial" pitchFamily="34" charset="-120"/>
+                <a:latin typeface="Cambria" pitchFamily="34" charset="0"/>
+                <a:ea typeface="Cambria" pitchFamily="34" charset="-122"/>
+                <a:cs typeface="Cambria" pitchFamily="34" charset="-120"/>
               </a:rPr>
               <a:t>Mosquitto</a:t>
             </a:r>
@@ -8390,11 +8620,11 @@
             </a:avLst>
           </a:prstGeom>
           <a:solidFill>
-            <a:srgbClr val="FF8A3D"/>
+            <a:srgbClr val="2E9E5B"/>
           </a:solidFill>
           <a:ln w="12700">
             <a:solidFill>
-              <a:srgbClr val="FF8A3D"/>
+              <a:srgbClr val="2E9E5B"/>
             </a:solidFill>
             <a:prstDash val="solid"/>
           </a:ln>
@@ -8429,9 +8659,9 @@
                 <a:solidFill>
                   <a:schemeClr val="bg1"/>
                 </a:solidFill>
-                <a:latin typeface="Arial" pitchFamily="34" charset="0"/>
-                <a:ea typeface="Arial" pitchFamily="34" charset="-122"/>
-                <a:cs typeface="Arial" pitchFamily="34" charset="-120"/>
+                <a:latin typeface="Cambria" pitchFamily="34" charset="0"/>
+                <a:ea typeface="Cambria" pitchFamily="34" charset="-122"/>
+                <a:cs typeface="Cambria" pitchFamily="34" charset="-120"/>
               </a:rPr>
               <a:t>IA vision</a:t>
             </a:r>
@@ -8512,11 +8742,11 @@
             </a:avLst>
           </a:prstGeom>
           <a:solidFill>
-            <a:srgbClr val="2EC4B6"/>
+            <a:srgbClr val="3A8F86"/>
           </a:solidFill>
           <a:ln w="12700">
             <a:solidFill>
-              <a:srgbClr val="2EC4B6"/>
+              <a:srgbClr val="3A8F86"/>
             </a:solidFill>
             <a:prstDash val="solid"/>
           </a:ln>
@@ -8551,9 +8781,9 @@
                 <a:solidFill>
                   <a:schemeClr val="bg1"/>
                 </a:solidFill>
-                <a:latin typeface="Arial" pitchFamily="34" charset="0"/>
-                <a:ea typeface="Arial" pitchFamily="34" charset="-122"/>
-                <a:cs typeface="Arial" pitchFamily="34" charset="-120"/>
+                <a:latin typeface="Cambria" pitchFamily="34" charset="0"/>
+                <a:ea typeface="Cambria" pitchFamily="34" charset="-122"/>
+                <a:cs typeface="Cambria" pitchFamily="34" charset="-120"/>
               </a:rPr>
               <a:t>Backend FastAPI</a:t>
             </a:r>
@@ -8634,11 +8864,11 @@
             </a:avLst>
           </a:prstGeom>
           <a:solidFill>
-            <a:srgbClr val="FF8A3D"/>
+            <a:srgbClr val="2E9E5B"/>
           </a:solidFill>
           <a:ln w="12700">
             <a:solidFill>
-              <a:srgbClr val="FF8A3D"/>
+              <a:srgbClr val="2E9E5B"/>
             </a:solidFill>
             <a:prstDash val="solid"/>
           </a:ln>
@@ -8673,9 +8903,9 @@
                 <a:solidFill>
                   <a:schemeClr val="bg1"/>
                 </a:solidFill>
-                <a:latin typeface="Arial" pitchFamily="34" charset="0"/>
-                <a:ea typeface="Arial" pitchFamily="34" charset="-122"/>
-                <a:cs typeface="Arial" pitchFamily="34" charset="-120"/>
+                <a:latin typeface="Cambria" pitchFamily="34" charset="0"/>
+                <a:ea typeface="Cambria" pitchFamily="34" charset="-122"/>
+                <a:cs typeface="Cambria" pitchFamily="34" charset="-120"/>
               </a:rPr>
               <a:t>IA prédictive</a:t>
             </a:r>
@@ -8739,11 +8969,11 @@
             </a:avLst>
           </a:prstGeom>
           <a:solidFill>
-            <a:srgbClr val="8D99AE"/>
+            <a:srgbClr val="8C969D"/>
           </a:solidFill>
           <a:ln w="12700">
             <a:solidFill>
-              <a:srgbClr val="8D99AE"/>
+              <a:srgbClr val="8C969D"/>
             </a:solidFill>
             <a:prstDash val="solid"/>
           </a:ln>
@@ -8778,9 +9008,9 @@
                 <a:solidFill>
                   <a:schemeClr val="bg1"/>
                 </a:solidFill>
-                <a:latin typeface="Arial" pitchFamily="34" charset="0"/>
-                <a:ea typeface="Arial" pitchFamily="34" charset="-122"/>
-                <a:cs typeface="Arial" pitchFamily="34" charset="-120"/>
+                <a:latin typeface="Cambria" pitchFamily="34" charset="0"/>
+                <a:ea typeface="Cambria" pitchFamily="34" charset="-122"/>
+                <a:cs typeface="Cambria" pitchFamily="34" charset="-120"/>
               </a:rPr>
               <a:t>PostgreSQL</a:t>
             </a:r>
@@ -8844,11 +9074,11 @@
             </a:avLst>
           </a:prstGeom>
           <a:solidFill>
-            <a:srgbClr val="5B8DEF"/>
+            <a:srgbClr val="1F6B42"/>
           </a:solidFill>
           <a:ln w="12700">
             <a:solidFill>
-              <a:srgbClr val="5B8DEF"/>
+              <a:srgbClr val="1F6B42"/>
             </a:solidFill>
             <a:prstDash val="solid"/>
           </a:ln>
@@ -8883,9 +9113,9 @@
                 <a:solidFill>
                   <a:schemeClr val="bg1"/>
                 </a:solidFill>
-                <a:latin typeface="Arial" pitchFamily="34" charset="0"/>
-                <a:ea typeface="Arial" pitchFamily="34" charset="-122"/>
-                <a:cs typeface="Arial" pitchFamily="34" charset="-120"/>
+                <a:latin typeface="Cambria" pitchFamily="34" charset="0"/>
+                <a:ea typeface="Cambria" pitchFamily="34" charset="-122"/>
+                <a:cs typeface="Cambria" pitchFamily="34" charset="-120"/>
               </a:rPr>
               <a:t>Dashboard React</a:t>
             </a:r>
@@ -8949,11 +9179,11 @@
             </a:avLst>
           </a:prstGeom>
           <a:solidFill>
-            <a:srgbClr val="8D99AE"/>
+            <a:srgbClr val="8C969D"/>
           </a:solidFill>
           <a:ln w="12700">
             <a:solidFill>
-              <a:srgbClr val="8D99AE"/>
+              <a:srgbClr val="8C969D"/>
             </a:solidFill>
             <a:prstDash val="solid"/>
           </a:ln>
@@ -8988,9 +9218,9 @@
                 <a:solidFill>
                   <a:schemeClr val="bg1"/>
                 </a:solidFill>
-                <a:latin typeface="Arial" pitchFamily="34" charset="0"/>
-                <a:ea typeface="Arial" pitchFamily="34" charset="-122"/>
-                <a:cs typeface="Arial" pitchFamily="34" charset="-120"/>
+                <a:latin typeface="Cambria" pitchFamily="34" charset="0"/>
+                <a:ea typeface="Cambria" pitchFamily="34" charset="-122"/>
+                <a:cs typeface="Cambria" pitchFamily="34" charset="-120"/>
               </a:rPr>
               <a:t>Grafana</a:t>
             </a:r>
@@ -9054,7 +9284,7 @@
           <a:noFill/>
           <a:ln w="25400">
             <a:solidFill>
-              <a:srgbClr val="1C2B3A"/>
+              <a:srgbClr val="353D44"/>
             </a:solidFill>
             <a:prstDash val="solid"/>
             <a:tailEnd type="triangle"/>
@@ -9078,7 +9308,7 @@
           <a:noFill/>
           <a:ln w="25400">
             <a:solidFill>
-              <a:srgbClr val="1C2B3A"/>
+              <a:srgbClr val="353D44"/>
             </a:solidFill>
             <a:prstDash val="solid"/>
             <a:tailEnd type="triangle"/>
@@ -9102,7 +9332,7 @@
           <a:noFill/>
           <a:ln w="25400">
             <a:solidFill>
-              <a:srgbClr val="1C2B3A"/>
+              <a:srgbClr val="353D44"/>
             </a:solidFill>
             <a:prstDash val="solid"/>
             <a:tailEnd type="triangle"/>
@@ -9126,7 +9356,7 @@
           <a:noFill/>
           <a:ln w="25400">
             <a:solidFill>
-              <a:srgbClr val="1C2B3A"/>
+              <a:srgbClr val="353D44"/>
             </a:solidFill>
             <a:prstDash val="solid"/>
             <a:tailEnd type="triangle"/>
@@ -9150,7 +9380,7 @@
           <a:noFill/>
           <a:ln w="25400">
             <a:solidFill>
-              <a:srgbClr val="1C2B3A"/>
+              <a:srgbClr val="353D44"/>
             </a:solidFill>
             <a:prstDash val="solid"/>
             <a:tailEnd type="triangle"/>
@@ -9174,7 +9404,7 @@
           <a:noFill/>
           <a:ln w="25400">
             <a:solidFill>
-              <a:srgbClr val="1C2B3A"/>
+              <a:srgbClr val="353D44"/>
             </a:solidFill>
             <a:prstDash val="solid"/>
             <a:tailEnd type="triangle"/>
@@ -9198,7 +9428,7 @@
           <a:noFill/>
           <a:ln w="25400">
             <a:solidFill>
-              <a:srgbClr val="1C2B3A"/>
+              <a:srgbClr val="353D44"/>
             </a:solidFill>
             <a:prstDash val="solid"/>
             <a:tailEnd type="triangle"/>
@@ -9222,7 +9452,7 @@
           <a:noFill/>
           <a:ln w="25400">
             <a:solidFill>
-              <a:srgbClr val="1C2B3A"/>
+              <a:srgbClr val="353D44"/>
             </a:solidFill>
             <a:prstDash val="solid"/>
             <a:tailEnd type="triangle"/>
@@ -9369,9 +9599,9 @@
                 <a:solidFill>
                   <a:schemeClr val="bg1"/>
                 </a:solidFill>
-                <a:latin typeface="Arial" pitchFamily="34" charset="0"/>
-                <a:ea typeface="Arial" pitchFamily="34" charset="-122"/>
-                <a:cs typeface="Arial" pitchFamily="34" charset="-120"/>
+                <a:latin typeface="Cambria" pitchFamily="34" charset="0"/>
+                <a:ea typeface="Cambria" pitchFamily="34" charset="-122"/>
+                <a:cs typeface="Cambria" pitchFamily="34" charset="-120"/>
               </a:rPr>
               <a:t>Démonstration : teaser « Sentinel Drop » puis live</a:t>
             </a:r>
@@ -9396,11 +9626,11 @@
             </a:avLst>
           </a:prstGeom>
           <a:solidFill>
-            <a:srgbClr val="1C2B3A"/>
+            <a:srgbClr val="353D44"/>
           </a:solidFill>
           <a:ln w="12700">
             <a:solidFill>
-              <a:srgbClr val="1C2B3A"/>
+              <a:srgbClr val="353D44"/>
             </a:solidFill>
             <a:prstDash val="solid"/>
           </a:ln>
@@ -9421,11 +9651,11 @@
             <a:avLst/>
           </a:prstGeom>
           <a:solidFill>
-            <a:srgbClr val="FF8A3D"/>
+            <a:srgbClr val="2E9E5B"/>
           </a:solidFill>
           <a:ln w="12700">
             <a:solidFill>
-              <a:srgbClr val="FF8A3D"/>
+              <a:srgbClr val="2E9E5B"/>
             </a:solidFill>
             <a:prstDash val="solid"/>
           </a:ln>
@@ -9563,7 +9793,7 @@
             <a:r>
               <a:rPr lang="en-US" sz="2200" b="1" dirty="0">
                 <a:solidFill>
-                  <a:schemeClr val="tx1"/>
+                  <a:schemeClr val="bg1"/>
                 </a:solidFill>
                 <a:latin typeface="Calibri" pitchFamily="34" charset="0"/>
                 <a:ea typeface="Calibri" pitchFamily="34" charset="-122"/>
@@ -9604,9 +9834,9 @@
                 <a:solidFill>
                   <a:schemeClr val="bg1"/>
                 </a:solidFill>
-                <a:latin typeface="Arial" pitchFamily="34" charset="0"/>
-                <a:ea typeface="Arial" pitchFamily="34" charset="-122"/>
-                <a:cs typeface="Arial" pitchFamily="34" charset="-120"/>
+                <a:latin typeface="Cambria" pitchFamily="34" charset="0"/>
+                <a:ea typeface="Cambria" pitchFamily="34" charset="-122"/>
+                <a:cs typeface="Cambria" pitchFamily="34" charset="-120"/>
               </a:rPr>
               <a:t>Surchauffe lente</a:t>
             </a:r>
@@ -9705,7 +9935,7 @@
             <a:r>
               <a:rPr lang="en-US" sz="2200" b="1" dirty="0">
                 <a:solidFill>
-                  <a:schemeClr val="tx1"/>
+                  <a:schemeClr val="bg1"/>
                 </a:solidFill>
                 <a:latin typeface="Calibri" pitchFamily="34" charset="0"/>
                 <a:ea typeface="Calibri" pitchFamily="34" charset="-122"/>
@@ -9746,9 +9976,9 @@
                 <a:solidFill>
                   <a:schemeClr val="bg1"/>
                 </a:solidFill>
-                <a:latin typeface="Arial" pitchFamily="34" charset="0"/>
-                <a:ea typeface="Arial" pitchFamily="34" charset="-122"/>
-                <a:cs typeface="Arial" pitchFamily="34" charset="-120"/>
+                <a:latin typeface="Cambria" pitchFamily="34" charset="0"/>
+                <a:ea typeface="Cambria" pitchFamily="34" charset="-122"/>
+                <a:cs typeface="Cambria" pitchFamily="34" charset="-120"/>
               </a:rPr>
               <a:t>Personne autorisée</a:t>
             </a:r>
@@ -9847,7 +10077,7 @@
             <a:r>
               <a:rPr lang="en-US" sz="2200" b="1" dirty="0">
                 <a:solidFill>
-                  <a:schemeClr val="tx1"/>
+                  <a:schemeClr val="bg1"/>
                 </a:solidFill>
                 <a:latin typeface="Calibri" pitchFamily="34" charset="0"/>
                 <a:ea typeface="Calibri" pitchFamily="34" charset="-122"/>
@@ -9888,9 +10118,9 @@
                 <a:solidFill>
                   <a:schemeClr val="bg1"/>
                 </a:solidFill>
-                <a:latin typeface="Arial" pitchFamily="34" charset="0"/>
-                <a:ea typeface="Arial" pitchFamily="34" charset="-122"/>
-                <a:cs typeface="Arial" pitchFamily="34" charset="-120"/>
+                <a:latin typeface="Cambria" pitchFamily="34" charset="0"/>
+                <a:ea typeface="Cambria" pitchFamily="34" charset="-122"/>
+                <a:cs typeface="Cambria" pitchFamily="34" charset="-120"/>
               </a:rPr>
               <a:t>Intrus 20 s</a:t>
             </a:r>
@@ -9989,7 +10219,7 @@
             <a:r>
               <a:rPr lang="en-US" sz="2200" b="1" dirty="0">
                 <a:solidFill>
-                  <a:schemeClr val="tx1"/>
+                  <a:schemeClr val="bg1"/>
                 </a:solidFill>
                 <a:latin typeface="Calibri" pitchFamily="34" charset="0"/>
                 <a:ea typeface="Calibri" pitchFamily="34" charset="-122"/>
@@ -10030,9 +10260,9 @@
                 <a:solidFill>
                   <a:schemeClr val="bg1"/>
                 </a:solidFill>
-                <a:latin typeface="Arial" pitchFamily="34" charset="0"/>
-                <a:ea typeface="Arial" pitchFamily="34" charset="-122"/>
-                <a:cs typeface="Arial" pitchFamily="34" charset="-120"/>
+                <a:latin typeface="Cambria" pitchFamily="34" charset="0"/>
+                <a:ea typeface="Cambria" pitchFamily="34" charset="-122"/>
+                <a:cs typeface="Cambria" pitchFamily="34" charset="-120"/>
               </a:rPr>
               <a:t>Superviseur</a:t>
             </a:r>
@@ -10180,9 +10410,9 @@
                 <a:solidFill>
                   <a:schemeClr val="tx1"/>
                 </a:solidFill>
-                <a:latin typeface="Arial" pitchFamily="34" charset="0"/>
-                <a:ea typeface="Arial" pitchFamily="34" charset="-122"/>
-                <a:cs typeface="Arial" pitchFamily="34" charset="-120"/>
+                <a:latin typeface="Cambria" pitchFamily="34" charset="0"/>
+                <a:ea typeface="Cambria" pitchFamily="34" charset="-122"/>
+                <a:cs typeface="Cambria" pitchFamily="34" charset="-120"/>
               </a:rPr>
               <a:t>IA vision : qui est là, et depuis combien de temps</a:t>
             </a:r>
@@ -10277,9 +10507,9 @@
                 <a:solidFill>
                   <a:schemeClr val="accent1"/>
                 </a:solidFill>
-                <a:latin typeface="Arial" pitchFamily="34" charset="0"/>
-                <a:ea typeface="Arial" pitchFamily="34" charset="-122"/>
-                <a:cs typeface="Arial" pitchFamily="34" charset="-120"/>
+                <a:latin typeface="Cambria" pitchFamily="34" charset="0"/>
+                <a:ea typeface="Cambria" pitchFamily="34" charset="-122"/>
+                <a:cs typeface="Cambria" pitchFamily="34" charset="-120"/>
               </a:rPr>
               <a:t>YOLOv8n</a:t>
             </a:r>
@@ -10355,9 +10585,9 @@
                 <a:solidFill>
                   <a:schemeClr val="accent1"/>
                 </a:solidFill>
-                <a:latin typeface="Arial" pitchFamily="34" charset="0"/>
-                <a:ea typeface="Arial" pitchFamily="34" charset="-122"/>
-                <a:cs typeface="Arial" pitchFamily="34" charset="-120"/>
+                <a:latin typeface="Cambria" pitchFamily="34" charset="0"/>
+                <a:ea typeface="Cambria" pitchFamily="34" charset="-122"/>
+                <a:cs typeface="Cambria" pitchFamily="34" charset="-120"/>
               </a:rPr>
               <a:t>Liste blanche</a:t>
             </a:r>
@@ -10433,9 +10663,9 @@
                 <a:solidFill>
                   <a:schemeClr val="accent1"/>
                 </a:solidFill>
-                <a:latin typeface="Arial" pitchFamily="34" charset="0"/>
-                <a:ea typeface="Arial" pitchFamily="34" charset="-122"/>
-                <a:cs typeface="Arial" pitchFamily="34" charset="-120"/>
+                <a:latin typeface="Cambria" pitchFamily="34" charset="0"/>
+                <a:ea typeface="Cambria" pitchFamily="34" charset="-122"/>
+                <a:cs typeface="Cambria" pitchFamily="34" charset="-120"/>
               </a:rPr>
               <a:t>Alarme à 20 s</a:t>
             </a:r>
@@ -10511,9 +10741,9 @@
                 <a:solidFill>
                   <a:schemeClr val="accent1"/>
                 </a:solidFill>
-                <a:latin typeface="Arial" pitchFamily="34" charset="0"/>
-                <a:ea typeface="Arial" pitchFamily="34" charset="-122"/>
-                <a:cs typeface="Arial" pitchFamily="34" charset="-120"/>
+                <a:latin typeface="Cambria" pitchFamily="34" charset="0"/>
+                <a:ea typeface="Cambria" pitchFamily="34" charset="-122"/>
+                <a:cs typeface="Cambria" pitchFamily="34" charset="-120"/>
               </a:rPr>
               <a:t>À chaud</a:t>
             </a:r>
@@ -10661,9 +10891,9 @@
                 <a:solidFill>
                   <a:schemeClr val="tx1"/>
                 </a:solidFill>
-                <a:latin typeface="Arial" pitchFamily="34" charset="0"/>
-                <a:ea typeface="Arial" pitchFamily="34" charset="-122"/>
-                <a:cs typeface="Arial" pitchFamily="34" charset="-120"/>
+                <a:latin typeface="Cambria" pitchFamily="34" charset="0"/>
+                <a:ea typeface="Cambria" pitchFamily="34" charset="-122"/>
+                <a:cs typeface="Cambria" pitchFamily="34" charset="-120"/>
               </a:rPr>
               <a:t>IA prédictive : alerter avant l'incident, sans seuil fixe</a:t>
             </a:r>
@@ -10727,11 +10957,11 @@
             </a:avLst>
           </a:prstGeom>
           <a:solidFill>
-            <a:srgbClr val="EEF2F6"/>
+            <a:srgbClr val="EEF3F0"/>
           </a:solidFill>
           <a:ln w="12700">
             <a:solidFill>
-              <a:srgbClr val="EEF2F6"/>
+              <a:srgbClr val="EEF3F0"/>
             </a:solidFill>
             <a:prstDash val="solid"/>
           </a:ln>
@@ -10764,11 +10994,11 @@
             <a:r>
               <a:rPr lang="en-US" sz="5200" b="1" dirty="0">
                 <a:solidFill>
-                  <a:srgbClr val="2EC4B6"/>
-                </a:solidFill>
-                <a:latin typeface="Arial" pitchFamily="34" charset="0"/>
-                <a:ea typeface="Arial" pitchFamily="34" charset="-122"/>
-                <a:cs typeface="Arial" pitchFamily="34" charset="-120"/>
+                  <a:srgbClr val="1F6B42"/>
+                </a:solidFill>
+                <a:latin typeface="Cambria" pitchFamily="34" charset="0"/>
+                <a:ea typeface="Cambria" pitchFamily="34" charset="-122"/>
+                <a:cs typeface="Cambria" pitchFamily="34" charset="-120"/>
               </a:rPr>
               <a:t>50/50</a:t>
             </a:r>
@@ -10832,11 +11062,11 @@
             </a:avLst>
           </a:prstGeom>
           <a:solidFill>
-            <a:srgbClr val="EEF2F6"/>
+            <a:srgbClr val="EEF3F0"/>
           </a:solidFill>
           <a:ln w="12700">
             <a:solidFill>
-              <a:srgbClr val="EEF2F6"/>
+              <a:srgbClr val="EEF3F0"/>
             </a:solidFill>
             <a:prstDash val="solid"/>
           </a:ln>
@@ -10869,11 +11099,11 @@
             <a:r>
               <a:rPr lang="en-US" sz="5200" b="1" dirty="0">
                 <a:solidFill>
-                  <a:srgbClr val="5B8DEF"/>
-                </a:solidFill>
-                <a:latin typeface="Arial" pitchFamily="34" charset="0"/>
-                <a:ea typeface="Arial" pitchFamily="34" charset="-122"/>
-                <a:cs typeface="Arial" pitchFamily="34" charset="-120"/>
+                  <a:srgbClr val="353D44"/>
+                </a:solidFill>
+                <a:latin typeface="Cambria" pitchFamily="34" charset="0"/>
+                <a:ea typeface="Cambria" pitchFamily="34" charset="-122"/>
+                <a:cs typeface="Cambria" pitchFamily="34" charset="-120"/>
               </a:rPr>
               <a:t>1/50</a:t>
             </a:r>
@@ -10937,11 +11167,11 @@
             </a:avLst>
           </a:prstGeom>
           <a:solidFill>
-            <a:srgbClr val="EEF2F6"/>
+            <a:srgbClr val="EEF3F0"/>
           </a:solidFill>
           <a:ln w="12700">
             <a:solidFill>
-              <a:srgbClr val="EEF2F6"/>
+              <a:srgbClr val="EEF3F0"/>
             </a:solidFill>
             <a:prstDash val="solid"/>
           </a:ln>
@@ -10974,11 +11204,11 @@
             <a:r>
               <a:rPr lang="en-US" sz="5200" b="1" dirty="0">
                 <a:solidFill>
-                  <a:srgbClr val="FF8A3D"/>
-                </a:solidFill>
-                <a:latin typeface="Arial" pitchFamily="34" charset="0"/>
-                <a:ea typeface="Arial" pitchFamily="34" charset="-122"/>
-                <a:cs typeface="Arial" pitchFamily="34" charset="-120"/>
+                  <a:srgbClr val="2E9E5B"/>
+                </a:solidFill>
+                <a:latin typeface="Cambria" pitchFamily="34" charset="0"/>
+                <a:ea typeface="Cambria" pitchFamily="34" charset="-122"/>
+                <a:cs typeface="Cambria" pitchFamily="34" charset="-120"/>
               </a:rPr>
               <a:t>436 s</a:t>
             </a:r>
@@ -11042,11 +11272,11 @@
             </a:avLst>
           </a:prstGeom>
           <a:solidFill>
-            <a:srgbClr val="EEF2F6"/>
+            <a:srgbClr val="EEF3F0"/>
           </a:solidFill>
           <a:ln w="12700">
             <a:solidFill>
-              <a:srgbClr val="EEF2F6"/>
+              <a:srgbClr val="EEF3F0"/>
             </a:solidFill>
             <a:prstDash val="solid"/>
           </a:ln>
@@ -11079,11 +11309,11 @@
             <a:r>
               <a:rPr lang="en-US" sz="5200" b="1" dirty="0">
                 <a:solidFill>
-                  <a:srgbClr val="E63946"/>
-                </a:solidFill>
-                <a:latin typeface="Arial" pitchFamily="34" charset="0"/>
-                <a:ea typeface="Arial" pitchFamily="34" charset="-122"/>
-                <a:cs typeface="Arial" pitchFamily="34" charset="-120"/>
+                  <a:srgbClr val="D64545"/>
+                </a:solidFill>
+                <a:latin typeface="Cambria" pitchFamily="34" charset="0"/>
+                <a:ea typeface="Cambria" pitchFamily="34" charset="-122"/>
+                <a:cs typeface="Cambria" pitchFamily="34" charset="-120"/>
               </a:rPr>
               <a:t>25 °C</a:t>
             </a:r>
@@ -11270,9 +11500,9 @@
                 <a:solidFill>
                   <a:schemeClr val="tx1"/>
                 </a:solidFill>
-                <a:latin typeface="Arial" pitchFamily="34" charset="0"/>
-                <a:ea typeface="Arial" pitchFamily="34" charset="-122"/>
-                <a:cs typeface="Arial" pitchFamily="34" charset="-120"/>
+                <a:latin typeface="Cambria" pitchFamily="34" charset="0"/>
+                <a:ea typeface="Cambria" pitchFamily="34" charset="-122"/>
+                <a:cs typeface="Cambria" pitchFamily="34" charset="-120"/>
               </a:rPr>
               <a:t>Supervision : dashboard opérateur et Grafana</a:t>
             </a:r>
@@ -11575,9 +11805,9 @@
                 <a:solidFill>
                   <a:schemeClr val="bg1"/>
                 </a:solidFill>
-                <a:latin typeface="Arial" pitchFamily="34" charset="0"/>
-                <a:ea typeface="Arial" pitchFamily="34" charset="-122"/>
-                <a:cs typeface="Arial" pitchFamily="34" charset="-120"/>
+                <a:latin typeface="Cambria" pitchFamily="34" charset="0"/>
+                <a:ea typeface="Cambria" pitchFamily="34" charset="-122"/>
+                <a:cs typeface="Cambria" pitchFamily="34" charset="-120"/>
               </a:rPr>
               <a:t>Sécurité : chiffré, authentifié, cloisonné</a:t>
             </a:r>
@@ -11614,9 +11844,9 @@
                 <a:solidFill>
                   <a:schemeClr val="accent2"/>
                 </a:solidFill>
-                <a:latin typeface="Arial" pitchFamily="34" charset="0"/>
-                <a:ea typeface="Arial" pitchFamily="34" charset="-122"/>
-                <a:cs typeface="Arial" pitchFamily="34" charset="-120"/>
+                <a:latin typeface="Cambria" pitchFamily="34" charset="0"/>
+                <a:ea typeface="Cambria" pitchFamily="34" charset="-122"/>
+                <a:cs typeface="Cambria" pitchFamily="34" charset="-120"/>
               </a:rPr>
               <a:t>7/7</a:t>
             </a:r>
@@ -11678,11 +11908,11 @@
             <a:avLst/>
           </a:prstGeom>
           <a:solidFill>
-            <a:srgbClr val="1C2B3A"/>
+            <a:srgbClr val="353D44"/>
           </a:solidFill>
           <a:ln w="12700">
             <a:solidFill>
-              <a:srgbClr val="1C2B3A"/>
+              <a:srgbClr val="353D44"/>
             </a:solidFill>
             <a:prstDash val="solid"/>
           </a:ln>
@@ -11741,9 +11971,9 @@
                 <a:solidFill>
                   <a:schemeClr val="bg1"/>
                 </a:solidFill>
-                <a:latin typeface="Arial" pitchFamily="34" charset="0"/>
-                <a:ea typeface="Arial" pitchFamily="34" charset="-122"/>
-                <a:cs typeface="Arial" pitchFamily="34" charset="-120"/>
+                <a:latin typeface="Cambria" pitchFamily="34" charset="0"/>
+                <a:ea typeface="Cambria" pitchFamily="34" charset="-122"/>
+                <a:cs typeface="Cambria" pitchFamily="34" charset="-120"/>
               </a:rPr>
               <a:t>MQTTS TLS 1.3</a:t>
             </a:r>
@@ -11805,11 +12035,11 @@
             <a:avLst/>
           </a:prstGeom>
           <a:solidFill>
-            <a:srgbClr val="1C2B3A"/>
+            <a:srgbClr val="353D44"/>
           </a:solidFill>
           <a:ln w="12700">
             <a:solidFill>
-              <a:srgbClr val="1C2B3A"/>
+              <a:srgbClr val="353D44"/>
             </a:solidFill>
             <a:prstDash val="solid"/>
           </a:ln>
@@ -11868,9 +12098,9 @@
                 <a:solidFill>
                   <a:schemeClr val="bg1"/>
                 </a:solidFill>
-                <a:latin typeface="Arial" pitchFamily="34" charset="0"/>
-                <a:ea typeface="Arial" pitchFamily="34" charset="-122"/>
-                <a:cs typeface="Arial" pitchFamily="34" charset="-120"/>
+                <a:latin typeface="Cambria" pitchFamily="34" charset="0"/>
+                <a:ea typeface="Cambria" pitchFamily="34" charset="-122"/>
+                <a:cs typeface="Cambria" pitchFamily="34" charset="-120"/>
               </a:rPr>
               <a:t>Comptes et ACL</a:t>
             </a:r>
@@ -11932,11 +12162,11 @@
             <a:avLst/>
           </a:prstGeom>
           <a:solidFill>
-            <a:srgbClr val="1C2B3A"/>
+            <a:srgbClr val="353D44"/>
           </a:solidFill>
           <a:ln w="12700">
             <a:solidFill>
-              <a:srgbClr val="1C2B3A"/>
+              <a:srgbClr val="353D44"/>
             </a:solidFill>
             <a:prstDash val="solid"/>
           </a:ln>
@@ -11995,9 +12225,9 @@
                 <a:solidFill>
                   <a:schemeClr val="bg1"/>
                 </a:solidFill>
-                <a:latin typeface="Arial" pitchFamily="34" charset="0"/>
-                <a:ea typeface="Arial" pitchFamily="34" charset="-122"/>
-                <a:cs typeface="Arial" pitchFamily="34" charset="-120"/>
+                <a:latin typeface="Cambria" pitchFamily="34" charset="0"/>
+                <a:ea typeface="Cambria" pitchFamily="34" charset="-122"/>
+                <a:cs typeface="Cambria" pitchFamily="34" charset="-120"/>
               </a:rPr>
               <a:t>Jetons séparés</a:t>
             </a:r>
@@ -12059,11 +12289,11 @@
             <a:avLst/>
           </a:prstGeom>
           <a:solidFill>
-            <a:srgbClr val="1C2B3A"/>
+            <a:srgbClr val="353D44"/>
           </a:solidFill>
           <a:ln w="12700">
             <a:solidFill>
-              <a:srgbClr val="1C2B3A"/>
+              <a:srgbClr val="353D44"/>
             </a:solidFill>
             <a:prstDash val="solid"/>
           </a:ln>
@@ -12122,9 +12352,9 @@
                 <a:solidFill>
                   <a:schemeClr val="bg1"/>
                 </a:solidFill>
-                <a:latin typeface="Arial" pitchFamily="34" charset="0"/>
-                <a:ea typeface="Arial" pitchFamily="34" charset="-122"/>
-                <a:cs typeface="Arial" pitchFamily="34" charset="-120"/>
+                <a:latin typeface="Cambria" pitchFamily="34" charset="0"/>
+                <a:ea typeface="Cambria" pitchFamily="34" charset="-122"/>
+                <a:cs typeface="Cambria" pitchFamily="34" charset="-120"/>
               </a:rPr>
               <a:t>Conteneurs durcis</a:t>
             </a:r>
@@ -12225,49 +12455,49 @@
 </file>
 
 <file path=ppt/theme/theme1.xml><?xml version="1.0" encoding="utf-8"?>
-<a:theme xmlns:a="http://schemas.openxmlformats.org/drawingml/2006/main" name="FORTEX Sentinel">
+<a:theme xmlns:a="http://schemas.openxmlformats.org/drawingml/2006/main" name="FORTEX Energie">
   <a:themeElements>
-    <a:clrScheme name="FORTEX Sentinel">
+    <a:clrScheme name="FORTEX Energie">
       <a:dk1>
-        <a:srgbClr val="0E1621"/>
+        <a:srgbClr val="23292E"/>
       </a:dk1>
       <a:lt1>
         <a:srgbClr val="FFFFFF"/>
       </a:lt1>
       <a:dk2>
-        <a:srgbClr val="1C2B3A"/>
+        <a:srgbClr val="353D44"/>
       </a:dk2>
       <a:lt2>
-        <a:srgbClr val="EEF2F6"/>
+        <a:srgbClr val="EEF3F0"/>
       </a:lt2>
       <a:accent1>
-        <a:srgbClr val="FF8A3D"/>
+        <a:srgbClr val="2E9E5B"/>
       </a:accent1>
       <a:accent2>
-        <a:srgbClr val="2EC4B6"/>
+        <a:srgbClr val="F2B84B"/>
       </a:accent2>
       <a:accent3>
-        <a:srgbClr val="E63946"/>
+        <a:srgbClr val="D64545"/>
       </a:accent3>
       <a:accent4>
-        <a:srgbClr val="F4C542"/>
+        <a:srgbClr val="3A8F86"/>
       </a:accent4>
       <a:accent5>
-        <a:srgbClr val="5B8DEF"/>
+        <a:srgbClr val="1F6B42"/>
       </a:accent5>
       <a:accent6>
-        <a:srgbClr val="8D99AE"/>
+        <a:srgbClr val="8C969D"/>
       </a:accent6>
       <a:hlink>
-        <a:srgbClr val="5B8DEF"/>
+        <a:srgbClr val="2E9E5B"/>
       </a:hlink>
       <a:folHlink>
-        <a:srgbClr val="8D99AE"/>
+        <a:srgbClr val="8C969D"/>
       </a:folHlink>
     </a:clrScheme>
-    <a:fontScheme name="FORTEX Sentinel">
+    <a:fontScheme name="FORTEX Energie">
       <a:majorFont>
-        <a:latin typeface="Arial"/>
+        <a:latin typeface="Cambria"/>
         <a:ea typeface=""/>
         <a:cs typeface=""/>
         <a:font script="Jpan" typeface="游ゴシック Light"/>

</xml_diff>